<commit_message>
Use real brand icons in the architecture diagram
Replace the hand-drawn shape glyphs on the architecture slide with
official brand logos (PNG, rasterized from Simple Icons and the
aws-icons architecture set): DigitalOcean for the five DO services,
Google Gemini, Meta (Llama 3.3), ElevenLabs, Qwen, Hugging Face,
AWS Amplify, and Amazon EC2. Icons live in presentation/icons/ and
are embedded by build_deck.py; AWS tiles now use their official
brand colors.

Co-Authored-By: Claude Fable 5 <noreply@anthropic.com>
Claude-Session: https://claude.ai/code/session_01UVwywFzSMEWXMQNU1FZDEQ
</commit_message>
<xml_diff>
--- a/presentation/reclaim-hackathon.pptx
+++ b/presentation/reclaim-hackathon.pptx
@@ -5559,14 +5559,14 @@
                             </p:stCondLst>
                             <p:childTnLst>
                               <p:par>
-                                <p:cTn id="645" presetID="42" presetClass="entr" presetSubtype="0" fill="hold" grpId="0" nodeType="afterEffect">
+                                <p:cTn id="593" presetID="42" presetClass="entr" presetSubtype="0" fill="hold" grpId="0" nodeType="afterEffect">
                                   <p:stCondLst>
                                     <p:cond delay="0"/>
                                   </p:stCondLst>
                                   <p:childTnLst>
                                     <p:set>
                                       <p:cBhvr>
-                                        <p:cTn id="646" dur="1" fill="hold">
+                                        <p:cTn id="594" dur="1" fill="hold">
                                           <p:stCondLst>
                                             <p:cond delay="0"/>
                                           </p:stCondLst>
@@ -5584,7 +5584,7 @@
                                     </p:set>
                                     <p:animEffect transition="in" filter="fade">
                                       <p:cBhvr>
-                                        <p:cTn id="647" dur="550"/>
+                                        <p:cTn id="595" dur="550"/>
                                         <p:tgtEl>
                                           <p:spTgt spid="11"/>
                                         </p:tgtEl>
@@ -5592,7 +5592,7 @@
                                     </p:animEffect>
                                     <p:anim calcmode="lin" valueType="num">
                                       <p:cBhvr additive="base">
-                                        <p:cTn id="648" dur="550" fill="hold"/>
+                                        <p:cTn id="596" dur="550" fill="hold"/>
                                         <p:tgtEl>
                                           <p:spTgt spid="11"/>
                                         </p:tgtEl>
@@ -5617,14 +5617,14 @@
                                 </p:cTn>
                               </p:par>
                               <p:par>
-                                <p:cTn id="649" presetID="42" presetClass="entr" presetSubtype="0" fill="hold" grpId="0" nodeType="withEffect">
+                                <p:cTn id="597" presetID="42" presetClass="entr" presetSubtype="0" fill="hold" grpId="0" nodeType="withEffect">
                                   <p:stCondLst>
                                     <p:cond delay="130"/>
                                   </p:stCondLst>
                                   <p:childTnLst>
                                     <p:set>
                                       <p:cBhvr>
-                                        <p:cTn id="650" dur="1" fill="hold">
+                                        <p:cTn id="598" dur="1" fill="hold">
                                           <p:stCondLst>
                                             <p:cond delay="0"/>
                                           </p:stCondLst>
@@ -5642,7 +5642,7 @@
                                     </p:set>
                                     <p:animEffect transition="in" filter="fade">
                                       <p:cBhvr>
-                                        <p:cTn id="651" dur="550"/>
+                                        <p:cTn id="599" dur="550"/>
                                         <p:tgtEl>
                                           <p:spTgt spid="12"/>
                                         </p:tgtEl>
@@ -5650,7 +5650,7 @@
                                     </p:animEffect>
                                     <p:anim calcmode="lin" valueType="num">
                                       <p:cBhvr additive="base">
-                                        <p:cTn id="652" dur="550" fill="hold"/>
+                                        <p:cTn id="600" dur="550" fill="hold"/>
                                         <p:tgtEl>
                                           <p:spTgt spid="12"/>
                                         </p:tgtEl>
@@ -5675,14 +5675,14 @@
                                 </p:cTn>
                               </p:par>
                               <p:par>
-                                <p:cTn id="653" presetID="42" presetClass="entr" presetSubtype="0" fill="hold" grpId="0" nodeType="withEffect">
+                                <p:cTn id="601" presetID="42" presetClass="entr" presetSubtype="0" fill="hold" grpId="0" nodeType="withEffect">
                                   <p:stCondLst>
                                     <p:cond delay="300"/>
                                   </p:stCondLst>
                                   <p:childTnLst>
                                     <p:set>
                                       <p:cBhvr>
-                                        <p:cTn id="654" dur="1" fill="hold">
+                                        <p:cTn id="602" dur="1" fill="hold">
                                           <p:stCondLst>
                                             <p:cond delay="0"/>
                                           </p:stCondLst>
@@ -5700,7 +5700,7 @@
                                     </p:set>
                                     <p:animEffect transition="in" filter="fade">
                                       <p:cBhvr>
-                                        <p:cTn id="655" dur="550"/>
+                                        <p:cTn id="603" dur="550"/>
                                         <p:tgtEl>
                                           <p:spTgt spid="15"/>
                                         </p:tgtEl>
@@ -5708,7 +5708,7 @@
                                     </p:animEffect>
                                     <p:anim calcmode="lin" valueType="num">
                                       <p:cBhvr additive="base">
-                                        <p:cTn id="656" dur="550" fill="hold"/>
+                                        <p:cTn id="604" dur="550" fill="hold"/>
                                         <p:tgtEl>
                                           <p:spTgt spid="15"/>
                                         </p:tgtEl>
@@ -5733,14 +5733,14 @@
                                 </p:cTn>
                               </p:par>
                               <p:par>
-                                <p:cTn id="657" presetID="42" presetClass="entr" presetSubtype="0" fill="hold" grpId="0" nodeType="withEffect">
+                                <p:cTn id="605" presetID="42" presetClass="entr" presetSubtype="0" fill="hold" grpId="0" nodeType="withEffect">
                                   <p:stCondLst>
                                     <p:cond delay="560"/>
                                   </p:stCondLst>
                                   <p:childTnLst>
                                     <p:set>
                                       <p:cBhvr>
-                                        <p:cTn id="658" dur="1" fill="hold">
+                                        <p:cTn id="606" dur="1" fill="hold">
                                           <p:stCondLst>
                                             <p:cond delay="0"/>
                                           </p:stCondLst>
@@ -5758,7 +5758,7 @@
                                     </p:set>
                                     <p:animEffect transition="in" filter="fade">
                                       <p:cBhvr>
-                                        <p:cTn id="659" dur="550"/>
+                                        <p:cTn id="607" dur="550"/>
                                         <p:tgtEl>
                                           <p:spTgt spid="18"/>
                                         </p:tgtEl>
@@ -5766,7 +5766,7 @@
                                     </p:animEffect>
                                     <p:anim calcmode="lin" valueType="num">
                                       <p:cBhvr additive="base">
-                                        <p:cTn id="660" dur="550" fill="hold"/>
+                                        <p:cTn id="608" dur="550" fill="hold"/>
                                         <p:tgtEl>
                                           <p:spTgt spid="18"/>
                                         </p:tgtEl>
@@ -5791,14 +5791,14 @@
                                 </p:cTn>
                               </p:par>
                               <p:par>
-                                <p:cTn id="661" presetID="42" presetClass="entr" presetSubtype="0" fill="hold" grpId="0" nodeType="withEffect">
+                                <p:cTn id="609" presetID="42" presetClass="entr" presetSubtype="0" fill="hold" grpId="0" nodeType="withEffect">
                                   <p:stCondLst>
                                     <p:cond delay="820"/>
                                   </p:stCondLst>
                                   <p:childTnLst>
                                     <p:set>
                                       <p:cBhvr>
-                                        <p:cTn id="662" dur="1" fill="hold">
+                                        <p:cTn id="610" dur="1" fill="hold">
                                           <p:stCondLst>
                                             <p:cond delay="0"/>
                                           </p:stCondLst>
@@ -5816,7 +5816,7 @@
                                     </p:set>
                                     <p:animEffect transition="in" filter="fade">
                                       <p:cBhvr>
-                                        <p:cTn id="663" dur="550"/>
+                                        <p:cTn id="611" dur="550"/>
                                         <p:tgtEl>
                                           <p:spTgt spid="21"/>
                                         </p:tgtEl>
@@ -5824,7 +5824,7 @@
                                     </p:animEffect>
                                     <p:anim calcmode="lin" valueType="num">
                                       <p:cBhvr additive="base">
-                                        <p:cTn id="664" dur="550" fill="hold"/>
+                                        <p:cTn id="612" dur="550" fill="hold"/>
                                         <p:tgtEl>
                                           <p:spTgt spid="21"/>
                                         </p:tgtEl>
@@ -5849,14 +5849,14 @@
                                 </p:cTn>
                               </p:par>
                               <p:par>
-                                <p:cTn id="665" presetID="10" presetClass="entr" presetSubtype="0" fill="hold" grpId="0" nodeType="withEffect">
+                                <p:cTn id="613" presetID="10" presetClass="entr" presetSubtype="0" fill="hold" grpId="0" nodeType="withEffect">
                                   <p:stCondLst>
                                     <p:cond delay="1150"/>
                                   </p:stCondLst>
                                   <p:childTnLst>
                                     <p:set>
                                       <p:cBhvr>
-                                        <p:cTn id="666" dur="1" fill="hold">
+                                        <p:cTn id="614" dur="1" fill="hold">
                                           <p:stCondLst>
                                             <p:cond delay="0"/>
                                           </p:stCondLst>
@@ -5874,7 +5874,7 @@
                                     </p:set>
                                     <p:animEffect transition="in" filter="fade">
                                       <p:cBhvr>
-                                        <p:cTn id="667" dur="550"/>
+                                        <p:cTn id="615" dur="550"/>
                                         <p:tgtEl>
                                           <p:spTgt spid="22"/>
                                         </p:tgtEl>
@@ -6559,14 +6559,14 @@
                             </p:stCondLst>
                             <p:childTnLst>
                               <p:par>
-                                <p:cTn id="669" presetID="42" presetClass="entr" presetSubtype="0" fill="hold" grpId="0" nodeType="afterEffect">
+                                <p:cTn id="617" presetID="42" presetClass="entr" presetSubtype="0" fill="hold" grpId="0" nodeType="afterEffect">
                                   <p:stCondLst>
                                     <p:cond delay="0"/>
                                   </p:stCondLst>
                                   <p:childTnLst>
                                     <p:set>
                                       <p:cBhvr>
-                                        <p:cTn id="670" dur="1" fill="hold">
+                                        <p:cTn id="618" dur="1" fill="hold">
                                           <p:stCondLst>
                                             <p:cond delay="0"/>
                                           </p:stCondLst>
@@ -6584,7 +6584,7 @@
                                     </p:set>
                                     <p:animEffect transition="in" filter="fade">
                                       <p:cBhvr>
-                                        <p:cTn id="671" dur="550"/>
+                                        <p:cTn id="619" dur="550"/>
                                         <p:tgtEl>
                                           <p:spTgt spid="9"/>
                                         </p:tgtEl>
@@ -6592,7 +6592,7 @@
                                     </p:animEffect>
                                     <p:anim calcmode="lin" valueType="num">
                                       <p:cBhvr additive="base">
-                                        <p:cTn id="672" dur="550" fill="hold"/>
+                                        <p:cTn id="620" dur="550" fill="hold"/>
                                         <p:tgtEl>
                                           <p:spTgt spid="9"/>
                                         </p:tgtEl>
@@ -6617,14 +6617,14 @@
                                 </p:cTn>
                               </p:par>
                               <p:par>
-                                <p:cTn id="673" presetID="42" presetClass="entr" presetSubtype="0" fill="hold" grpId="0" nodeType="withEffect">
+                                <p:cTn id="621" presetID="42" presetClass="entr" presetSubtype="0" fill="hold" grpId="0" nodeType="withEffect">
                                   <p:stCondLst>
                                     <p:cond delay="300"/>
                                   </p:stCondLst>
                                   <p:childTnLst>
                                     <p:set>
                                       <p:cBhvr>
-                                        <p:cTn id="674" dur="1" fill="hold">
+                                        <p:cTn id="622" dur="1" fill="hold">
                                           <p:stCondLst>
                                             <p:cond delay="0"/>
                                           </p:stCondLst>
@@ -6642,7 +6642,7 @@
                                     </p:set>
                                     <p:animEffect transition="in" filter="fade">
                                       <p:cBhvr>
-                                        <p:cTn id="675" dur="550"/>
+                                        <p:cTn id="623" dur="550"/>
                                         <p:tgtEl>
                                           <p:spTgt spid="10"/>
                                         </p:tgtEl>
@@ -6650,7 +6650,7 @@
                                     </p:animEffect>
                                     <p:anim calcmode="lin" valueType="num">
                                       <p:cBhvr additive="base">
-                                        <p:cTn id="676" dur="550" fill="hold"/>
+                                        <p:cTn id="624" dur="550" fill="hold"/>
                                         <p:tgtEl>
                                           <p:spTgt spid="10"/>
                                         </p:tgtEl>
@@ -6675,14 +6675,14 @@
                                 </p:cTn>
                               </p:par>
                               <p:par>
-                                <p:cTn id="677" presetID="10" presetClass="entr" presetSubtype="0" fill="hold" grpId="0" nodeType="withEffect">
+                                <p:cTn id="625" presetID="10" presetClass="entr" presetSubtype="0" fill="hold" grpId="0" nodeType="withEffect">
                                   <p:stCondLst>
                                     <p:cond delay="500"/>
                                   </p:stCondLst>
                                   <p:childTnLst>
                                     <p:set>
                                       <p:cBhvr>
-                                        <p:cTn id="678" dur="1" fill="hold">
+                                        <p:cTn id="626" dur="1" fill="hold">
                                           <p:stCondLst>
                                             <p:cond delay="0"/>
                                           </p:stCondLst>
@@ -6700,7 +6700,7 @@
                                     </p:set>
                                     <p:animEffect transition="in" filter="fade">
                                       <p:cBhvr>
-                                        <p:cTn id="679" dur="550"/>
+                                        <p:cTn id="627" dur="550"/>
                                         <p:tgtEl>
                                           <p:spTgt spid="12"/>
                                         </p:tgtEl>
@@ -18882,10 +18882,10 @@
           <a:gradFill rotWithShape="1">
             <a:gsLst>
               <a:gs pos="0">
-                <a:srgbClr val="E11D48"/>
+                <a:srgbClr val="DD344C"/>
               </a:gs>
               <a:gs pos="100000">
-                <a:srgbClr val="E11D48"/>
+                <a:srgbClr val="DD344C"/>
               </a:gs>
             </a:gsLst>
             <a:lin ang="5400000" scaled="1"/>
@@ -18913,71 +18913,34 @@
           </a:p>
         </p:txBody>
       </p:sp>
-      <p:sp>
-        <p:nvSpPr>
-          <p:cNvPr id="13" name="Donut 12"/>
-          <p:cNvSpPr/>
-          <p:nvPr/>
-        </p:nvSpPr>
-        <p:spPr>
-          <a:xfrm>
-            <a:off x="1152144" y="2221992"/>
-            <a:ext cx="164592" cy="164592"/>
-          </a:xfrm>
-          <a:prstGeom prst="donut">
+      <p:pic>
+        <p:nvPicPr>
+          <p:cNvPr id="13" name="Picture 12" descr="awsamplify.png"/>
+          <p:cNvPicPr>
+            <a:picLocks noChangeAspect="1"/>
+          </p:cNvPicPr>
+          <p:nvPr/>
+        </p:nvPicPr>
+        <p:blipFill>
+          <a:blip r:embed="rId2"/>
+          <a:stretch>
+            <a:fillRect/>
+          </a:stretch>
+        </p:blipFill>
+        <p:spPr>
+          <a:xfrm>
+            <a:off x="950976" y="2093976"/>
+            <a:ext cx="566928" cy="566928"/>
+          </a:xfrm>
+          <a:prstGeom prst="rect">
             <a:avLst/>
           </a:prstGeom>
           <a:effectLst/>
-          <a:solidFill>
-            <a:srgbClr val="FFFFFF"/>
-          </a:solidFill>
-          <a:ln>
-            <a:noFill/>
-          </a:ln>
-        </p:spPr>
-        <p:txBody>
-          <a:bodyPr rtlCol="0" anchor="ctr"/>
-          <a:lstStyle/>
-          <a:p>
-            <a:pPr algn="ctr"/>
-          </a:p>
-        </p:txBody>
-      </p:sp>
-      <p:sp>
-        <p:nvSpPr>
-          <p:cNvPr id="14" name="Rounded Rectangle 13"/>
-          <p:cNvSpPr/>
-          <p:nvPr/>
-        </p:nvSpPr>
-        <p:spPr>
-          <a:xfrm>
-            <a:off x="1115568" y="2340864"/>
-            <a:ext cx="237744" cy="182880"/>
-          </a:xfrm>
-          <a:prstGeom prst="roundRect">
-            <a:avLst>
-              <a:gd name="adj" fmla="val 20000"/>
-            </a:avLst>
-          </a:prstGeom>
-          <a:effectLst/>
-          <a:solidFill>
-            <a:srgbClr val="FFFFFF"/>
-          </a:solidFill>
-          <a:ln>
-            <a:noFill/>
-          </a:ln>
-        </p:spPr>
-        <p:txBody>
-          <a:bodyPr rtlCol="0" anchor="ctr"/>
-          <a:lstStyle/>
-          <a:p>
-            <a:pPr algn="ctr"/>
-          </a:p>
-        </p:txBody>
-      </p:sp>
-      <p:sp>
-        <p:nvSpPr>
-          <p:cNvPr id="15" name="TextBox 14"/>
+        </p:spPr>
+      </p:pic>
+      <p:sp>
+        <p:nvSpPr>
+          <p:cNvPr id="14" name="TextBox 13"/>
           <p:cNvSpPr txBox="1"/>
           <p:nvPr/>
         </p:nvSpPr>
@@ -19020,7 +18983,7 @@
       </p:sp>
       <p:sp>
         <p:nvSpPr>
-          <p:cNvPr id="16" name="Rectangle 15"/>
+          <p:cNvPr id="15" name="Rectangle 14"/>
           <p:cNvSpPr/>
           <p:nvPr/>
         </p:nvSpPr>
@@ -19054,7 +19017,7 @@
       </p:sp>
       <p:sp>
         <p:nvSpPr>
-          <p:cNvPr id="17" name="Rounded Rectangle 16"/>
+          <p:cNvPr id="16" name="Rounded Rectangle 15"/>
           <p:cNvSpPr/>
           <p:nvPr/>
         </p:nvSpPr>
@@ -19086,7 +19049,7 @@
       </p:sp>
       <p:sp>
         <p:nvSpPr>
-          <p:cNvPr id="18" name="Rectangle 17"/>
+          <p:cNvPr id="17" name="Rectangle 16"/>
           <p:cNvSpPr/>
           <p:nvPr/>
         </p:nvSpPr>
@@ -19116,7 +19079,7 @@
       </p:sp>
       <p:sp>
         <p:nvSpPr>
-          <p:cNvPr id="19" name="TextBox 18"/>
+          <p:cNvPr id="18" name="TextBox 17"/>
           <p:cNvSpPr txBox="1"/>
           <p:nvPr/>
         </p:nvSpPr>
@@ -19155,7 +19118,7 @@
       </p:sp>
       <p:sp>
         <p:nvSpPr>
-          <p:cNvPr id="20" name="TextBox 19"/>
+          <p:cNvPr id="19" name="TextBox 18"/>
           <p:cNvSpPr txBox="1"/>
           <p:nvPr/>
         </p:nvSpPr>
@@ -19194,7 +19157,7 @@
       </p:sp>
       <p:sp>
         <p:nvSpPr>
-          <p:cNvPr id="21" name="Rounded Rectangle 20"/>
+          <p:cNvPr id="20" name="Rounded Rectangle 19"/>
           <p:cNvSpPr/>
           <p:nvPr/>
         </p:nvSpPr>
@@ -19243,39 +19206,34 @@
           </a:p>
         </p:txBody>
       </p:sp>
-      <p:sp>
-        <p:nvSpPr>
-          <p:cNvPr id="22" name="Cloud 21"/>
-          <p:cNvSpPr/>
-          <p:nvPr/>
-        </p:nvSpPr>
-        <p:spPr>
-          <a:xfrm>
-            <a:off x="4114800" y="3675888"/>
-            <a:ext cx="365760" cy="237744"/>
-          </a:xfrm>
-          <a:prstGeom prst="cloud">
+      <p:pic>
+        <p:nvPicPr>
+          <p:cNvPr id="21" name="Picture 20" descr="digitalocean.png"/>
+          <p:cNvPicPr>
+            <a:picLocks noChangeAspect="1"/>
+          </p:cNvPicPr>
+          <p:nvPr/>
+        </p:nvPicPr>
+        <p:blipFill>
+          <a:blip r:embed="rId3"/>
+          <a:stretch>
+            <a:fillRect/>
+          </a:stretch>
+        </p:blipFill>
+        <p:spPr>
+          <a:xfrm>
+            <a:off x="4096512" y="3593592"/>
+            <a:ext cx="402336" cy="402336"/>
+          </a:xfrm>
+          <a:prstGeom prst="rect">
             <a:avLst/>
           </a:prstGeom>
           <a:effectLst/>
-          <a:noFill/>
-          <a:ln w="25400">
-            <a:solidFill>
-              <a:srgbClr val="FFFFFF"/>
-            </a:solidFill>
-          </a:ln>
-        </p:spPr>
-        <p:txBody>
-          <a:bodyPr rtlCol="0" anchor="ctr"/>
-          <a:lstStyle/>
-          <a:p>
-            <a:pPr algn="ctr"/>
-          </a:p>
-        </p:txBody>
-      </p:sp>
-      <p:sp>
-        <p:nvSpPr>
-          <p:cNvPr id="23" name="TextBox 22"/>
+        </p:spPr>
+      </p:pic>
+      <p:sp>
+        <p:nvSpPr>
+          <p:cNvPr id="22" name="TextBox 21"/>
           <p:cNvSpPr txBox="1"/>
           <p:nvPr/>
         </p:nvSpPr>
@@ -19318,7 +19276,7 @@
       </p:sp>
       <p:sp>
         <p:nvSpPr>
-          <p:cNvPr id="24" name="Rounded Rectangle 23"/>
+          <p:cNvPr id="23" name="Rounded Rectangle 22"/>
           <p:cNvSpPr/>
           <p:nvPr/>
         </p:nvSpPr>
@@ -19367,71 +19325,34 @@
           </a:p>
         </p:txBody>
       </p:sp>
-      <p:sp>
-        <p:nvSpPr>
-          <p:cNvPr id="25" name="Rounded Rectangle 24"/>
-          <p:cNvSpPr/>
-          <p:nvPr/>
-        </p:nvSpPr>
-        <p:spPr>
-          <a:xfrm>
-            <a:off x="4114800" y="1435608"/>
-            <a:ext cx="256032" cy="237744"/>
-          </a:xfrm>
-          <a:prstGeom prst="roundRect">
-            <a:avLst>
-              <a:gd name="adj" fmla="val 25000"/>
-            </a:avLst>
+      <p:pic>
+        <p:nvPicPr>
+          <p:cNvPr id="24" name="Picture 23" descr="googlegemini.png"/>
+          <p:cNvPicPr>
+            <a:picLocks noChangeAspect="1"/>
+          </p:cNvPicPr>
+          <p:nvPr/>
+        </p:nvPicPr>
+        <p:blipFill>
+          <a:blip r:embed="rId4"/>
+          <a:stretch>
+            <a:fillRect/>
+          </a:stretch>
+        </p:blipFill>
+        <p:spPr>
+          <a:xfrm>
+            <a:off x="4096512" y="1353312"/>
+            <a:ext cx="402336" cy="402336"/>
+          </a:xfrm>
+          <a:prstGeom prst="rect">
+            <a:avLst/>
           </a:prstGeom>
           <a:effectLst/>
-          <a:noFill/>
-          <a:ln w="25400">
-            <a:solidFill>
-              <a:srgbClr val="FFFFFF"/>
-            </a:solidFill>
-          </a:ln>
-        </p:spPr>
-        <p:txBody>
-          <a:bodyPr rtlCol="0" anchor="ctr"/>
-          <a:lstStyle/>
-          <a:p>
-            <a:pPr algn="ctr"/>
-          </a:p>
-        </p:txBody>
-      </p:sp>
-      <p:sp>
-        <p:nvSpPr>
-          <p:cNvPr id="26" name="Isosceles Triangle 25"/>
-          <p:cNvSpPr/>
-          <p:nvPr/>
-        </p:nvSpPr>
-        <p:spPr>
-          <a:xfrm rot="16200000">
-            <a:off x="4389120" y="1463040"/>
-            <a:ext cx="128016" cy="182880"/>
-          </a:xfrm>
-          <a:prstGeom prst="triangle">
-            <a:avLst/>
-          </a:prstGeom>
-          <a:effectLst/>
-          <a:solidFill>
-            <a:srgbClr val="FFFFFF"/>
-          </a:solidFill>
-          <a:ln>
-            <a:noFill/>
-          </a:ln>
-        </p:spPr>
-        <p:txBody>
-          <a:bodyPr rtlCol="0" anchor="ctr"/>
-          <a:lstStyle/>
-          <a:p>
-            <a:pPr algn="ctr"/>
-          </a:p>
-        </p:txBody>
-      </p:sp>
-      <p:sp>
-        <p:nvSpPr>
-          <p:cNvPr id="27" name="TextBox 26"/>
+        </p:spPr>
+      </p:pic>
+      <p:sp>
+        <p:nvSpPr>
+          <p:cNvPr id="25" name="TextBox 24"/>
           <p:cNvSpPr txBox="1"/>
           <p:nvPr/>
         </p:nvSpPr>
@@ -19474,7 +19395,7 @@
       </p:sp>
       <p:sp>
         <p:nvSpPr>
-          <p:cNvPr id="28" name="Rounded Rectangle 27"/>
+          <p:cNvPr id="26" name="Rounded Rectangle 25"/>
           <p:cNvSpPr/>
           <p:nvPr/>
         </p:nvSpPr>
@@ -19523,129 +19444,34 @@
           </a:p>
         </p:txBody>
       </p:sp>
-      <p:sp>
-        <p:nvSpPr>
-          <p:cNvPr id="29" name="Oval 28"/>
-          <p:cNvSpPr/>
-          <p:nvPr/>
-        </p:nvSpPr>
-        <p:spPr>
-          <a:xfrm>
-            <a:off x="6236208" y="1408176"/>
-            <a:ext cx="91440" cy="91440"/>
-          </a:xfrm>
-          <a:prstGeom prst="ellipse">
+      <p:pic>
+        <p:nvPicPr>
+          <p:cNvPr id="27" name="Picture 26" descr="digitalocean.png"/>
+          <p:cNvPicPr>
+            <a:picLocks noChangeAspect="1"/>
+          </p:cNvPicPr>
+          <p:nvPr/>
+        </p:nvPicPr>
+        <p:blipFill>
+          <a:blip r:embed="rId3"/>
+          <a:stretch>
+            <a:fillRect/>
+          </a:stretch>
+        </p:blipFill>
+        <p:spPr>
+          <a:xfrm>
+            <a:off x="6199632" y="1353312"/>
+            <a:ext cx="402336" cy="402336"/>
+          </a:xfrm>
+          <a:prstGeom prst="rect">
             <a:avLst/>
           </a:prstGeom>
           <a:effectLst/>
-          <a:solidFill>
-            <a:srgbClr val="FFFFFF"/>
-          </a:solidFill>
-          <a:ln>
-            <a:noFill/>
-          </a:ln>
-        </p:spPr>
-        <p:txBody>
-          <a:bodyPr rtlCol="0" anchor="ctr"/>
-          <a:lstStyle/>
-          <a:p>
-            <a:pPr algn="ctr"/>
-          </a:p>
-        </p:txBody>
-      </p:sp>
-      <p:sp>
-        <p:nvSpPr>
-          <p:cNvPr id="30" name="Oval 29"/>
-          <p:cNvSpPr/>
-          <p:nvPr/>
-        </p:nvSpPr>
-        <p:spPr>
-          <a:xfrm>
-            <a:off x="6451092" y="1431036"/>
-            <a:ext cx="118872" cy="118872"/>
-          </a:xfrm>
-          <a:prstGeom prst="ellipse">
-            <a:avLst/>
-          </a:prstGeom>
-          <a:effectLst/>
-          <a:solidFill>
-            <a:srgbClr val="FFFFFF"/>
-          </a:solidFill>
-          <a:ln>
-            <a:noFill/>
-          </a:ln>
-        </p:spPr>
-        <p:txBody>
-          <a:bodyPr rtlCol="0" anchor="ctr"/>
-          <a:lstStyle/>
-          <a:p>
-            <a:pPr algn="ctr"/>
-          </a:p>
-        </p:txBody>
-      </p:sp>
-      <p:sp>
-        <p:nvSpPr>
-          <p:cNvPr id="31" name="Oval 30"/>
-          <p:cNvSpPr/>
-          <p:nvPr/>
-        </p:nvSpPr>
-        <p:spPr>
-          <a:xfrm>
-            <a:off x="6327648" y="1600200"/>
-            <a:ext cx="91440" cy="91440"/>
-          </a:xfrm>
-          <a:prstGeom prst="ellipse">
-            <a:avLst/>
-          </a:prstGeom>
-          <a:effectLst/>
-          <a:solidFill>
-            <a:srgbClr val="FFFFFF"/>
-          </a:solidFill>
-          <a:ln>
-            <a:noFill/>
-          </a:ln>
-        </p:spPr>
-        <p:txBody>
-          <a:bodyPr rtlCol="0" anchor="ctr"/>
-          <a:lstStyle/>
-          <a:p>
-            <a:pPr algn="ctr"/>
-          </a:p>
-        </p:txBody>
-      </p:sp>
-      <p:sp>
-        <p:nvSpPr>
-          <p:cNvPr id="32" name="Oval 31"/>
-          <p:cNvSpPr/>
-          <p:nvPr/>
-        </p:nvSpPr>
-        <p:spPr>
-          <a:xfrm>
-            <a:off x="6455664" y="1636776"/>
-            <a:ext cx="73152" cy="73152"/>
-          </a:xfrm>
-          <a:prstGeom prst="ellipse">
-            <a:avLst/>
-          </a:prstGeom>
-          <a:effectLst/>
-          <a:solidFill>
-            <a:srgbClr val="FFFFFF"/>
-          </a:solidFill>
-          <a:ln>
-            <a:noFill/>
-          </a:ln>
-        </p:spPr>
-        <p:txBody>
-          <a:bodyPr rtlCol="0" anchor="ctr"/>
-          <a:lstStyle/>
-          <a:p>
-            <a:pPr algn="ctr"/>
-          </a:p>
-        </p:txBody>
-      </p:sp>
-      <p:sp>
-        <p:nvSpPr>
-          <p:cNvPr id="33" name="TextBox 32"/>
+        </p:spPr>
+      </p:pic>
+      <p:sp>
+        <p:nvSpPr>
+          <p:cNvPr id="28" name="TextBox 27"/>
           <p:cNvSpPr txBox="1"/>
           <p:nvPr/>
         </p:nvSpPr>
@@ -19688,7 +19514,7 @@
       </p:sp>
       <p:sp>
         <p:nvSpPr>
-          <p:cNvPr id="34" name="Rounded Rectangle 33"/>
+          <p:cNvPr id="29" name="Rounded Rectangle 28"/>
           <p:cNvSpPr/>
           <p:nvPr/>
         </p:nvSpPr>
@@ -19737,39 +19563,34 @@
           </a:p>
         </p:txBody>
       </p:sp>
-      <p:sp>
-        <p:nvSpPr>
-          <p:cNvPr id="35" name="Can 34"/>
-          <p:cNvSpPr/>
-          <p:nvPr/>
-        </p:nvSpPr>
-        <p:spPr>
-          <a:xfrm>
-            <a:off x="8467344" y="1408176"/>
-            <a:ext cx="256032" cy="292608"/>
-          </a:xfrm>
-          <a:prstGeom prst="can">
+      <p:pic>
+        <p:nvPicPr>
+          <p:cNvPr id="30" name="Picture 29" descr="digitalocean.png"/>
+          <p:cNvPicPr>
+            <a:picLocks noChangeAspect="1"/>
+          </p:cNvPicPr>
+          <p:nvPr/>
+        </p:nvPicPr>
+        <p:blipFill>
+          <a:blip r:embed="rId3"/>
+          <a:stretch>
+            <a:fillRect/>
+          </a:stretch>
+        </p:blipFill>
+        <p:spPr>
+          <a:xfrm>
+            <a:off x="8394192" y="1353312"/>
+            <a:ext cx="402336" cy="402336"/>
+          </a:xfrm>
+          <a:prstGeom prst="rect">
             <a:avLst/>
           </a:prstGeom>
           <a:effectLst/>
-          <a:noFill/>
-          <a:ln w="25400">
-            <a:solidFill>
-              <a:srgbClr val="FFFFFF"/>
-            </a:solidFill>
-          </a:ln>
-        </p:spPr>
-        <p:txBody>
-          <a:bodyPr rtlCol="0" anchor="ctr"/>
-          <a:lstStyle/>
-          <a:p>
-            <a:pPr algn="ctr"/>
-          </a:p>
-        </p:txBody>
-      </p:sp>
-      <p:sp>
-        <p:nvSpPr>
-          <p:cNvPr id="36" name="TextBox 35"/>
+        </p:spPr>
+      </p:pic>
+      <p:sp>
+        <p:nvSpPr>
+          <p:cNvPr id="31" name="TextBox 30"/>
           <p:cNvSpPr txBox="1"/>
           <p:nvPr/>
         </p:nvSpPr>
@@ -19812,7 +19633,7 @@
       </p:sp>
       <p:sp>
         <p:nvSpPr>
-          <p:cNvPr id="37" name="Rounded Rectangle 36"/>
+          <p:cNvPr id="32" name="Rounded Rectangle 31"/>
           <p:cNvSpPr/>
           <p:nvPr/>
         </p:nvSpPr>
@@ -19861,39 +19682,34 @@
           </a:p>
         </p:txBody>
       </p:sp>
-      <p:sp>
-        <p:nvSpPr>
-          <p:cNvPr id="38" name="4-Point Star 37"/>
-          <p:cNvSpPr/>
-          <p:nvPr/>
-        </p:nvSpPr>
-        <p:spPr>
-          <a:xfrm>
-            <a:off x="6245352" y="3639312"/>
-            <a:ext cx="310896" cy="310896"/>
-          </a:xfrm>
-          <a:prstGeom prst="star4">
+      <p:pic>
+        <p:nvPicPr>
+          <p:cNvPr id="33" name="Picture 32" descr="meta.png"/>
+          <p:cNvPicPr>
+            <a:picLocks noChangeAspect="1"/>
+          </p:cNvPicPr>
+          <p:nvPr/>
+        </p:nvPicPr>
+        <p:blipFill>
+          <a:blip r:embed="rId5"/>
+          <a:stretch>
+            <a:fillRect/>
+          </a:stretch>
+        </p:blipFill>
+        <p:spPr>
+          <a:xfrm>
+            <a:off x="6199632" y="3593592"/>
+            <a:ext cx="402336" cy="402336"/>
+          </a:xfrm>
+          <a:prstGeom prst="rect">
             <a:avLst/>
           </a:prstGeom>
           <a:effectLst/>
-          <a:solidFill>
-            <a:srgbClr val="FFFFFF"/>
-          </a:solidFill>
-          <a:ln>
-            <a:noFill/>
-          </a:ln>
-        </p:spPr>
-        <p:txBody>
-          <a:bodyPr rtlCol="0" anchor="ctr"/>
-          <a:lstStyle/>
-          <a:p>
-            <a:pPr algn="ctr"/>
-          </a:p>
-        </p:txBody>
-      </p:sp>
-      <p:sp>
-        <p:nvSpPr>
-          <p:cNvPr id="39" name="TextBox 38"/>
+        </p:spPr>
+      </p:pic>
+      <p:sp>
+        <p:nvSpPr>
+          <p:cNvPr id="34" name="TextBox 33"/>
           <p:cNvSpPr txBox="1"/>
           <p:nvPr/>
         </p:nvSpPr>
@@ -19936,7 +19752,7 @@
       </p:sp>
       <p:sp>
         <p:nvSpPr>
-          <p:cNvPr id="40" name="Rounded Rectangle 39"/>
+          <p:cNvPr id="35" name="Rounded Rectangle 34"/>
           <p:cNvSpPr/>
           <p:nvPr/>
         </p:nvSpPr>
@@ -19985,169 +19801,34 @@
           </a:p>
         </p:txBody>
       </p:sp>
-      <p:sp>
-        <p:nvSpPr>
-          <p:cNvPr id="41" name="Rounded Rectangle 40"/>
-          <p:cNvSpPr/>
-          <p:nvPr/>
-        </p:nvSpPr>
-        <p:spPr>
-          <a:xfrm>
-            <a:off x="8441284" y="3779215"/>
-            <a:ext cx="41148" cy="170993"/>
-          </a:xfrm>
-          <a:prstGeom prst="roundRect">
-            <a:avLst>
-              <a:gd name="adj" fmla="val 50000"/>
-            </a:avLst>
+      <p:pic>
+        <p:nvPicPr>
+          <p:cNvPr id="36" name="Picture 35" descr="elevenlabs.png"/>
+          <p:cNvPicPr>
+            <a:picLocks noChangeAspect="1"/>
+          </p:cNvPicPr>
+          <p:nvPr/>
+        </p:nvPicPr>
+        <p:blipFill>
+          <a:blip r:embed="rId6"/>
+          <a:stretch>
+            <a:fillRect/>
+          </a:stretch>
+        </p:blipFill>
+        <p:spPr>
+          <a:xfrm>
+            <a:off x="8394192" y="3593592"/>
+            <a:ext cx="402336" cy="402336"/>
+          </a:xfrm>
+          <a:prstGeom prst="rect">
+            <a:avLst/>
           </a:prstGeom>
           <a:effectLst/>
-          <a:solidFill>
-            <a:srgbClr val="FFFFFF"/>
-          </a:solidFill>
-          <a:ln>
-            <a:noFill/>
-          </a:ln>
-        </p:spPr>
-        <p:txBody>
-          <a:bodyPr rtlCol="0" anchor="ctr"/>
-          <a:lstStyle/>
-          <a:p>
-            <a:pPr algn="ctr"/>
-          </a:p>
-        </p:txBody>
-      </p:sp>
-      <p:sp>
-        <p:nvSpPr>
-          <p:cNvPr id="42" name="Rounded Rectangle 41"/>
-          <p:cNvSpPr/>
-          <p:nvPr/>
-        </p:nvSpPr>
-        <p:spPr>
-          <a:xfrm>
-            <a:off x="8508035" y="3685946"/>
-            <a:ext cx="41148" cy="264262"/>
-          </a:xfrm>
-          <a:prstGeom prst="roundRect">
-            <a:avLst>
-              <a:gd name="adj" fmla="val 50000"/>
-            </a:avLst>
-          </a:prstGeom>
-          <a:effectLst/>
-          <a:solidFill>
-            <a:srgbClr val="FFFFFF"/>
-          </a:solidFill>
-          <a:ln>
-            <a:noFill/>
-          </a:ln>
-        </p:spPr>
-        <p:txBody>
-          <a:bodyPr rtlCol="0" anchor="ctr"/>
-          <a:lstStyle/>
-          <a:p>
-            <a:pPr algn="ctr"/>
-          </a:p>
-        </p:txBody>
-      </p:sp>
-      <p:sp>
-        <p:nvSpPr>
-          <p:cNvPr id="43" name="Rounded Rectangle 42"/>
-          <p:cNvSpPr/>
-          <p:nvPr/>
-        </p:nvSpPr>
-        <p:spPr>
-          <a:xfrm>
-            <a:off x="8574786" y="3639312"/>
-            <a:ext cx="41148" cy="310896"/>
-          </a:xfrm>
-          <a:prstGeom prst="roundRect">
-            <a:avLst>
-              <a:gd name="adj" fmla="val 50000"/>
-            </a:avLst>
-          </a:prstGeom>
-          <a:effectLst/>
-          <a:solidFill>
-            <a:srgbClr val="FFFFFF"/>
-          </a:solidFill>
-          <a:ln>
-            <a:noFill/>
-          </a:ln>
-        </p:spPr>
-        <p:txBody>
-          <a:bodyPr rtlCol="0" anchor="ctr"/>
-          <a:lstStyle/>
-          <a:p>
-            <a:pPr algn="ctr"/>
-          </a:p>
-        </p:txBody>
-      </p:sp>
-      <p:sp>
-        <p:nvSpPr>
-          <p:cNvPr id="44" name="Rounded Rectangle 43"/>
-          <p:cNvSpPr/>
-          <p:nvPr/>
-        </p:nvSpPr>
-        <p:spPr>
-          <a:xfrm>
-            <a:off x="8641537" y="3732581"/>
-            <a:ext cx="41148" cy="217627"/>
-          </a:xfrm>
-          <a:prstGeom prst="roundRect">
-            <a:avLst>
-              <a:gd name="adj" fmla="val 50000"/>
-            </a:avLst>
-          </a:prstGeom>
-          <a:effectLst/>
-          <a:solidFill>
-            <a:srgbClr val="FFFFFF"/>
-          </a:solidFill>
-          <a:ln>
-            <a:noFill/>
-          </a:ln>
-        </p:spPr>
-        <p:txBody>
-          <a:bodyPr rtlCol="0" anchor="ctr"/>
-          <a:lstStyle/>
-          <a:p>
-            <a:pPr algn="ctr"/>
-          </a:p>
-        </p:txBody>
-      </p:sp>
-      <p:sp>
-        <p:nvSpPr>
-          <p:cNvPr id="45" name="Rounded Rectangle 44"/>
-          <p:cNvSpPr/>
-          <p:nvPr/>
-        </p:nvSpPr>
-        <p:spPr>
-          <a:xfrm>
-            <a:off x="8708288" y="3810305"/>
-            <a:ext cx="41148" cy="139903"/>
-          </a:xfrm>
-          <a:prstGeom prst="roundRect">
-            <a:avLst>
-              <a:gd name="adj" fmla="val 50000"/>
-            </a:avLst>
-          </a:prstGeom>
-          <a:effectLst/>
-          <a:solidFill>
-            <a:srgbClr val="FFFFFF"/>
-          </a:solidFill>
-          <a:ln>
-            <a:noFill/>
-          </a:ln>
-        </p:spPr>
-        <p:txBody>
-          <a:bodyPr rtlCol="0" anchor="ctr"/>
-          <a:lstStyle/>
-          <a:p>
-            <a:pPr algn="ctr"/>
-          </a:p>
-        </p:txBody>
-      </p:sp>
-      <p:sp>
-        <p:nvSpPr>
-          <p:cNvPr id="46" name="TextBox 45"/>
+        </p:spPr>
+      </p:pic>
+      <p:sp>
+        <p:nvSpPr>
+          <p:cNvPr id="37" name="TextBox 36"/>
           <p:cNvSpPr txBox="1"/>
           <p:nvPr/>
         </p:nvSpPr>
@@ -20190,7 +19871,7 @@
       </p:sp>
       <p:sp>
         <p:nvSpPr>
-          <p:cNvPr id="47" name="Rounded Rectangle 46"/>
+          <p:cNvPr id="38" name="Rounded Rectangle 37"/>
           <p:cNvSpPr/>
           <p:nvPr/>
         </p:nvSpPr>
@@ -20239,39 +19920,34 @@
           </a:p>
         </p:txBody>
       </p:sp>
-      <p:sp>
-        <p:nvSpPr>
-          <p:cNvPr id="48" name="Lightning Bolt 47"/>
-          <p:cNvSpPr/>
-          <p:nvPr/>
-        </p:nvSpPr>
-        <p:spPr>
-          <a:xfrm>
-            <a:off x="10579608" y="3639312"/>
-            <a:ext cx="237744" cy="310896"/>
-          </a:xfrm>
-          <a:prstGeom prst="lightningBolt">
+      <p:pic>
+        <p:nvPicPr>
+          <p:cNvPr id="39" name="Picture 38" descr="digitalocean.png"/>
+          <p:cNvPicPr>
+            <a:picLocks noChangeAspect="1"/>
+          </p:cNvPicPr>
+          <p:nvPr/>
+        </p:nvPicPr>
+        <p:blipFill>
+          <a:blip r:embed="rId3"/>
+          <a:stretch>
+            <a:fillRect/>
+          </a:stretch>
+        </p:blipFill>
+        <p:spPr>
+          <a:xfrm>
+            <a:off x="10497312" y="3593592"/>
+            <a:ext cx="402336" cy="402336"/>
+          </a:xfrm>
+          <a:prstGeom prst="rect">
             <a:avLst/>
           </a:prstGeom>
           <a:effectLst/>
-          <a:solidFill>
-            <a:srgbClr val="FFFFFF"/>
-          </a:solidFill>
-          <a:ln>
-            <a:noFill/>
-          </a:ln>
-        </p:spPr>
-        <p:txBody>
-          <a:bodyPr rtlCol="0" anchor="ctr"/>
-          <a:lstStyle/>
-          <a:p>
-            <a:pPr algn="ctr"/>
-          </a:p>
-        </p:txBody>
-      </p:sp>
-      <p:sp>
-        <p:nvSpPr>
-          <p:cNvPr id="49" name="TextBox 48"/>
+        </p:spPr>
+      </p:pic>
+      <p:sp>
+        <p:nvSpPr>
+          <p:cNvPr id="40" name="TextBox 39"/>
           <p:cNvSpPr txBox="1"/>
           <p:nvPr/>
         </p:nvSpPr>
@@ -20314,7 +19990,7 @@
       </p:sp>
       <p:sp>
         <p:nvSpPr>
-          <p:cNvPr id="50" name="Rounded Rectangle 49"/>
+          <p:cNvPr id="41" name="Rounded Rectangle 40"/>
           <p:cNvSpPr/>
           <p:nvPr/>
         </p:nvSpPr>
@@ -20363,71 +20039,34 @@
           </a:p>
         </p:txBody>
       </p:sp>
-      <p:sp>
-        <p:nvSpPr>
-          <p:cNvPr id="51" name="Rounded Rectangle 50"/>
-          <p:cNvSpPr/>
-          <p:nvPr/>
-        </p:nvSpPr>
-        <p:spPr>
-          <a:xfrm>
-            <a:off x="2377440" y="5669280"/>
-            <a:ext cx="274320" cy="274320"/>
-          </a:xfrm>
-          <a:prstGeom prst="roundRect">
-            <a:avLst>
-              <a:gd name="adj" fmla="val 12000"/>
-            </a:avLst>
-          </a:prstGeom>
-          <a:effectLst/>
-          <a:noFill/>
-          <a:ln w="25400">
-            <a:solidFill>
-              <a:srgbClr val="FFFFFF"/>
-            </a:solidFill>
-          </a:ln>
-        </p:spPr>
-        <p:txBody>
-          <a:bodyPr rtlCol="0" anchor="ctr"/>
-          <a:lstStyle/>
-          <a:p>
-            <a:pPr algn="ctr"/>
-          </a:p>
-        </p:txBody>
-      </p:sp>
-      <p:sp>
-        <p:nvSpPr>
-          <p:cNvPr id="52" name="Rectangle 51"/>
-          <p:cNvSpPr/>
-          <p:nvPr/>
-        </p:nvSpPr>
-        <p:spPr>
-          <a:xfrm>
-            <a:off x="2459736" y="5751576"/>
-            <a:ext cx="109728" cy="109728"/>
+      <p:pic>
+        <p:nvPicPr>
+          <p:cNvPr id="42" name="Picture 41" descr="digitalocean.png"/>
+          <p:cNvPicPr>
+            <a:picLocks noChangeAspect="1"/>
+          </p:cNvPicPr>
+          <p:nvPr/>
+        </p:nvPicPr>
+        <p:blipFill>
+          <a:blip r:embed="rId3"/>
+          <a:stretch>
+            <a:fillRect/>
+          </a:stretch>
+        </p:blipFill>
+        <p:spPr>
+          <a:xfrm>
+            <a:off x="2313432" y="5605272"/>
+            <a:ext cx="402336" cy="402336"/>
           </a:xfrm>
           <a:prstGeom prst="rect">
             <a:avLst/>
           </a:prstGeom>
           <a:effectLst/>
-          <a:solidFill>
-            <a:srgbClr val="FFFFFF"/>
-          </a:solidFill>
-          <a:ln>
-            <a:noFill/>
-          </a:ln>
-        </p:spPr>
-        <p:txBody>
-          <a:bodyPr rtlCol="0" anchor="ctr"/>
-          <a:lstStyle/>
-          <a:p>
-            <a:pPr algn="ctr"/>
-          </a:p>
-        </p:txBody>
-      </p:sp>
-      <p:sp>
-        <p:nvSpPr>
-          <p:cNvPr id="53" name="TextBox 52"/>
+        </p:spPr>
+      </p:pic>
+      <p:sp>
+        <p:nvSpPr>
+          <p:cNvPr id="43" name="TextBox 42"/>
           <p:cNvSpPr txBox="1"/>
           <p:nvPr/>
         </p:nvSpPr>
@@ -20470,7 +20109,7 @@
       </p:sp>
       <p:sp>
         <p:nvSpPr>
-          <p:cNvPr id="54" name="Rounded Rectangle 53"/>
+          <p:cNvPr id="44" name="Rounded Rectangle 43"/>
           <p:cNvSpPr/>
           <p:nvPr/>
         </p:nvSpPr>
@@ -20488,10 +20127,10 @@
           <a:gradFill rotWithShape="1">
             <a:gsLst>
               <a:gs pos="0">
-                <a:srgbClr val="FF9900"/>
+                <a:srgbClr val="ED7100"/>
               </a:gs>
               <a:gs pos="100000">
-                <a:srgbClr val="FF9900"/>
+                <a:srgbClr val="ED7100"/>
               </a:gs>
             </a:gsLst>
             <a:lin ang="5400000" scaled="1"/>
@@ -20519,71 +20158,34 @@
           </a:p>
         </p:txBody>
       </p:sp>
-      <p:sp>
-        <p:nvSpPr>
-          <p:cNvPr id="55" name="Rounded Rectangle 54"/>
-          <p:cNvSpPr/>
-          <p:nvPr/>
-        </p:nvSpPr>
-        <p:spPr>
-          <a:xfrm>
-            <a:off x="4572000" y="5669280"/>
-            <a:ext cx="274320" cy="274320"/>
-          </a:xfrm>
-          <a:prstGeom prst="roundRect">
-            <a:avLst>
-              <a:gd name="adj" fmla="val 12000"/>
-            </a:avLst>
-          </a:prstGeom>
-          <a:effectLst/>
-          <a:noFill/>
-          <a:ln w="25400">
-            <a:solidFill>
-              <a:srgbClr val="FFFFFF"/>
-            </a:solidFill>
-          </a:ln>
-        </p:spPr>
-        <p:txBody>
-          <a:bodyPr rtlCol="0" anchor="ctr"/>
-          <a:lstStyle/>
-          <a:p>
-            <a:pPr algn="ctr"/>
-          </a:p>
-        </p:txBody>
-      </p:sp>
-      <p:sp>
-        <p:nvSpPr>
-          <p:cNvPr id="56" name="Rectangle 55"/>
-          <p:cNvSpPr/>
-          <p:nvPr/>
-        </p:nvSpPr>
-        <p:spPr>
-          <a:xfrm>
-            <a:off x="4654296" y="5751576"/>
-            <a:ext cx="109728" cy="109728"/>
+      <p:pic>
+        <p:nvPicPr>
+          <p:cNvPr id="45" name="Picture 44" descr="amazonec2.png"/>
+          <p:cNvPicPr>
+            <a:picLocks noChangeAspect="1"/>
+          </p:cNvPicPr>
+          <p:nvPr/>
+        </p:nvPicPr>
+        <p:blipFill>
+          <a:blip r:embed="rId7"/>
+          <a:stretch>
+            <a:fillRect/>
+          </a:stretch>
+        </p:blipFill>
+        <p:spPr>
+          <a:xfrm>
+            <a:off x="4425696" y="5522976"/>
+            <a:ext cx="566928" cy="566928"/>
           </a:xfrm>
           <a:prstGeom prst="rect">
             <a:avLst/>
           </a:prstGeom>
           <a:effectLst/>
-          <a:solidFill>
-            <a:srgbClr val="FFFFFF"/>
-          </a:solidFill>
-          <a:ln>
-            <a:noFill/>
-          </a:ln>
-        </p:spPr>
-        <p:txBody>
-          <a:bodyPr rtlCol="0" anchor="ctr"/>
-          <a:lstStyle/>
-          <a:p>
-            <a:pPr algn="ctr"/>
-          </a:p>
-        </p:txBody>
-      </p:sp>
-      <p:sp>
-        <p:nvSpPr>
-          <p:cNvPr id="57" name="TextBox 56"/>
+        </p:spPr>
+      </p:pic>
+      <p:sp>
+        <p:nvSpPr>
+          <p:cNvPr id="46" name="TextBox 45"/>
           <p:cNvSpPr txBox="1"/>
           <p:nvPr/>
         </p:nvSpPr>
@@ -20626,7 +20228,7 @@
       </p:sp>
       <p:sp>
         <p:nvSpPr>
-          <p:cNvPr id="58" name="Rounded Rectangle 57"/>
+          <p:cNvPr id="47" name="Rounded Rectangle 46"/>
           <p:cNvSpPr/>
           <p:nvPr/>
         </p:nvSpPr>
@@ -20675,48 +20277,34 @@
           </a:p>
         </p:txBody>
       </p:sp>
-      <p:sp>
-        <p:nvSpPr>
-          <p:cNvPr id="59" name="TextBox 58"/>
-          <p:cNvSpPr txBox="1"/>
-          <p:nvPr/>
-        </p:nvSpPr>
-        <p:spPr>
-          <a:xfrm>
-            <a:off x="6629400" y="5650992"/>
-            <a:ext cx="548640" cy="310896"/>
+      <p:pic>
+        <p:nvPicPr>
+          <p:cNvPr id="48" name="Picture 47" descr="huggingface.png"/>
+          <p:cNvPicPr>
+            <a:picLocks noChangeAspect="1"/>
+          </p:cNvPicPr>
+          <p:nvPr/>
+        </p:nvPicPr>
+        <p:blipFill>
+          <a:blip r:embed="rId8"/>
+          <a:stretch>
+            <a:fillRect/>
+          </a:stretch>
+        </p:blipFill>
+        <p:spPr>
+          <a:xfrm>
+            <a:off x="6702552" y="5605272"/>
+            <a:ext cx="402336" cy="402336"/>
           </a:xfrm>
           <a:prstGeom prst="rect">
             <a:avLst/>
           </a:prstGeom>
-          <a:noFill/>
-        </p:spPr>
-        <p:txBody>
-          <a:bodyPr wrap="square" anchor="ctr" lIns="0" rIns="0" tIns="0" bIns="0">
-            <a:spAutoFit/>
-          </a:bodyPr>
-          <a:lstStyle/>
-          <a:p>
-            <a:pPr algn="ctr">
-              <a:spcAft>
-                <a:spcPts val="0"/>
-              </a:spcAft>
-            </a:pPr>
-            <a:r>
-              <a:rPr sz="1500" b="1" i="0">
-                <a:solidFill>
-                  <a:srgbClr val="1C1917"/>
-                </a:solidFill>
-                <a:latin typeface="Segoe UI"/>
-              </a:rPr>
-              <a:t>HF</a:t>
-            </a:r>
-          </a:p>
-        </p:txBody>
-      </p:sp>
-      <p:sp>
-        <p:nvSpPr>
-          <p:cNvPr id="60" name="TextBox 59"/>
+          <a:effectLst/>
+        </p:spPr>
+      </p:pic>
+      <p:sp>
+        <p:nvSpPr>
+          <p:cNvPr id="49" name="TextBox 48"/>
           <p:cNvSpPr txBox="1"/>
           <p:nvPr/>
         </p:nvSpPr>
@@ -20759,7 +20347,7 @@
       </p:sp>
       <p:sp>
         <p:nvSpPr>
-          <p:cNvPr id="61" name="Rounded Rectangle 60"/>
+          <p:cNvPr id="50" name="Rounded Rectangle 49"/>
           <p:cNvSpPr/>
           <p:nvPr/>
         </p:nvSpPr>
@@ -20808,101 +20396,34 @@
           </a:p>
         </p:txBody>
       </p:sp>
-      <p:sp>
-        <p:nvSpPr>
-          <p:cNvPr id="62" name="Rectangle 61"/>
-          <p:cNvSpPr/>
-          <p:nvPr/>
-        </p:nvSpPr>
-        <p:spPr>
-          <a:xfrm>
-            <a:off x="8942832" y="5742432"/>
-            <a:ext cx="91440" cy="128016"/>
+      <p:pic>
+        <p:nvPicPr>
+          <p:cNvPr id="51" name="Picture 50" descr="qwen.png"/>
+          <p:cNvPicPr>
+            <a:picLocks noChangeAspect="1"/>
+          </p:cNvPicPr>
+          <p:nvPr/>
+        </p:nvPicPr>
+        <p:blipFill>
+          <a:blip r:embed="rId9"/>
+          <a:stretch>
+            <a:fillRect/>
+          </a:stretch>
+        </p:blipFill>
+        <p:spPr>
+          <a:xfrm>
+            <a:off x="8897112" y="5605272"/>
+            <a:ext cx="402336" cy="402336"/>
           </a:xfrm>
           <a:prstGeom prst="rect">
             <a:avLst/>
           </a:prstGeom>
           <a:effectLst/>
-          <a:solidFill>
-            <a:srgbClr val="FFFFFF"/>
-          </a:solidFill>
-          <a:ln>
-            <a:noFill/>
-          </a:ln>
-        </p:spPr>
-        <p:txBody>
-          <a:bodyPr rtlCol="0" anchor="ctr"/>
-          <a:lstStyle/>
-          <a:p>
-            <a:pPr algn="ctr"/>
-          </a:p>
-        </p:txBody>
-      </p:sp>
-      <p:sp>
-        <p:nvSpPr>
-          <p:cNvPr id="63" name="Isosceles Triangle 62"/>
-          <p:cNvSpPr/>
-          <p:nvPr/>
-        </p:nvSpPr>
-        <p:spPr>
-          <a:xfrm rot="5400000">
-            <a:off x="8988552" y="5669280"/>
-            <a:ext cx="201168" cy="274320"/>
-          </a:xfrm>
-          <a:prstGeom prst="triangle">
-            <a:avLst/>
-          </a:prstGeom>
-          <a:effectLst/>
-          <a:solidFill>
-            <a:srgbClr val="FFFFFF"/>
-          </a:solidFill>
-          <a:ln>
-            <a:noFill/>
-          </a:ln>
-        </p:spPr>
-        <p:txBody>
-          <a:bodyPr rtlCol="0" anchor="ctr"/>
-          <a:lstStyle/>
-          <a:p>
-            <a:pPr algn="ctr"/>
-          </a:p>
-        </p:txBody>
-      </p:sp>
-      <p:sp>
-        <p:nvSpPr>
-          <p:cNvPr id="64" name="Rounded Rectangle 63"/>
-          <p:cNvSpPr/>
-          <p:nvPr/>
-        </p:nvSpPr>
-        <p:spPr>
-          <a:xfrm>
-            <a:off x="9217152" y="5724144"/>
-            <a:ext cx="32004" cy="164592"/>
-          </a:xfrm>
-          <a:prstGeom prst="roundRect">
-            <a:avLst>
-              <a:gd name="adj" fmla="val 50000"/>
-            </a:avLst>
-          </a:prstGeom>
-          <a:effectLst/>
-          <a:solidFill>
-            <a:srgbClr val="FFFFFF"/>
-          </a:solidFill>
-          <a:ln>
-            <a:noFill/>
-          </a:ln>
-        </p:spPr>
-        <p:txBody>
-          <a:bodyPr rtlCol="0" anchor="ctr"/>
-          <a:lstStyle/>
-          <a:p>
-            <a:pPr algn="ctr"/>
-          </a:p>
-        </p:txBody>
-      </p:sp>
-      <p:sp>
-        <p:nvSpPr>
-          <p:cNvPr id="65" name="TextBox 64"/>
+        </p:spPr>
+      </p:pic>
+      <p:sp>
+        <p:nvSpPr>
+          <p:cNvPr id="52" name="TextBox 51"/>
           <p:cNvSpPr txBox="1"/>
           <p:nvPr/>
         </p:nvSpPr>
@@ -20945,7 +20466,7 @@
       </p:sp>
       <p:cxnSp>
         <p:nvCxnSpPr>
-          <p:cNvPr id="66" name="Connector 65"/>
+          <p:cNvPr id="53" name="Connector 52"/>
           <p:cNvCxnSpPr/>
           <p:nvPr/>
         </p:nvCxnSpPr>
@@ -20971,7 +20492,7 @@
       </p:cxnSp>
       <p:cxnSp>
         <p:nvCxnSpPr>
-          <p:cNvPr id="67" name="Connector 66"/>
+          <p:cNvPr id="54" name="Connector 53"/>
           <p:cNvCxnSpPr/>
           <p:nvPr/>
         </p:nvCxnSpPr>
@@ -20997,7 +20518,7 @@
       </p:cxnSp>
       <p:cxnSp>
         <p:nvCxnSpPr>
-          <p:cNvPr id="68" name="Connector 67"/>
+          <p:cNvPr id="55" name="Connector 54"/>
           <p:cNvCxnSpPr/>
           <p:nvPr/>
         </p:nvCxnSpPr>
@@ -21023,7 +20544,7 @@
       </p:cxnSp>
       <p:cxnSp>
         <p:nvCxnSpPr>
-          <p:cNvPr id="69" name="Connector 68"/>
+          <p:cNvPr id="56" name="Connector 55"/>
           <p:cNvCxnSpPr/>
           <p:nvPr/>
         </p:nvCxnSpPr>
@@ -21049,7 +20570,7 @@
       </p:cxnSp>
       <p:cxnSp>
         <p:nvCxnSpPr>
-          <p:cNvPr id="70" name="Connector 69"/>
+          <p:cNvPr id="57" name="Connector 56"/>
           <p:cNvCxnSpPr/>
           <p:nvPr/>
         </p:nvCxnSpPr>
@@ -21075,7 +20596,7 @@
       </p:cxnSp>
       <p:cxnSp>
         <p:nvCxnSpPr>
-          <p:cNvPr id="71" name="Connector 70"/>
+          <p:cNvPr id="58" name="Connector 57"/>
           <p:cNvCxnSpPr/>
           <p:nvPr/>
         </p:nvCxnSpPr>
@@ -21101,7 +20622,7 @@
       </p:cxnSp>
       <p:cxnSp>
         <p:nvCxnSpPr>
-          <p:cNvPr id="72" name="Connector 71"/>
+          <p:cNvPr id="59" name="Connector 58"/>
           <p:cNvCxnSpPr/>
           <p:nvPr/>
         </p:nvCxnSpPr>
@@ -21127,7 +20648,7 @@
       </p:cxnSp>
       <p:cxnSp>
         <p:nvCxnSpPr>
-          <p:cNvPr id="73" name="Connector 72"/>
+          <p:cNvPr id="60" name="Connector 59"/>
           <p:cNvCxnSpPr/>
           <p:nvPr/>
         </p:nvCxnSpPr>
@@ -21153,7 +20674,7 @@
       </p:cxnSp>
       <p:cxnSp>
         <p:nvCxnSpPr>
-          <p:cNvPr id="74" name="Connector 73"/>
+          <p:cNvPr id="61" name="Connector 60"/>
           <p:cNvCxnSpPr/>
           <p:nvPr/>
         </p:nvCxnSpPr>
@@ -21180,7 +20701,7 @@
       </p:cxnSp>
       <p:cxnSp>
         <p:nvCxnSpPr>
-          <p:cNvPr id="75" name="Connector 74"/>
+          <p:cNvPr id="62" name="Connector 61"/>
           <p:cNvCxnSpPr/>
           <p:nvPr/>
         </p:nvCxnSpPr>
@@ -21206,7 +20727,7 @@
       </p:cxnSp>
       <p:cxnSp>
         <p:nvCxnSpPr>
-          <p:cNvPr id="76" name="Connector 75"/>
+          <p:cNvPr id="63" name="Connector 62"/>
           <p:cNvCxnSpPr/>
           <p:nvPr/>
         </p:nvCxnSpPr>
@@ -21233,7 +20754,7 @@
       </p:cxnSp>
       <p:cxnSp>
         <p:nvCxnSpPr>
-          <p:cNvPr id="77" name="Connector 76"/>
+          <p:cNvPr id="64" name="Connector 63"/>
           <p:cNvCxnSpPr/>
           <p:nvPr/>
         </p:nvCxnSpPr>
@@ -21370,7 +20891,7 @@
                                           </p:stCondLst>
                                         </p:cTn>
                                         <p:tgtEl>
-                                          <p:spTgt spid="16"/>
+                                          <p:spTgt spid="15"/>
                                         </p:tgtEl>
                                         <p:attrNameLst>
                                           <p:attrName>style.visibility</p:attrName>
@@ -21384,7 +20905,7 @@
                                       <p:cBhvr>
                                         <p:cTn id="359" dur="550"/>
                                         <p:tgtEl>
-                                          <p:spTgt spid="16"/>
+                                          <p:spTgt spid="15"/>
                                         </p:tgtEl>
                                       </p:cBhvr>
                                     </p:animEffect>
@@ -21405,7 +20926,7 @@
                                           </p:stCondLst>
                                         </p:cTn>
                                         <p:tgtEl>
-                                          <p:spTgt spid="17"/>
+                                          <p:spTgt spid="16"/>
                                         </p:tgtEl>
                                         <p:attrNameLst>
                                           <p:attrName>style.visibility</p:attrName>
@@ -21419,7 +20940,7 @@
                                       <p:cBhvr>
                                         <p:cTn id="363" dur="550"/>
                                         <p:tgtEl>
-                                          <p:spTgt spid="17"/>
+                                          <p:spTgt spid="16"/>
                                         </p:tgtEl>
                                       </p:cBhvr>
                                     </p:animEffect>
@@ -21440,7 +20961,7 @@
                                           </p:stCondLst>
                                         </p:cTn>
                                         <p:tgtEl>
-                                          <p:spTgt spid="18"/>
+                                          <p:spTgt spid="17"/>
                                         </p:tgtEl>
                                         <p:attrNameLst>
                                           <p:attrName>style.visibility</p:attrName>
@@ -21454,7 +20975,7 @@
                                       <p:cBhvr>
                                         <p:cTn id="367" dur="550"/>
                                         <p:tgtEl>
-                                          <p:spTgt spid="18"/>
+                                          <p:spTgt spid="17"/>
                                         </p:tgtEl>
                                       </p:cBhvr>
                                     </p:animEffect>
@@ -21475,7 +20996,7 @@
                                           </p:stCondLst>
                                         </p:cTn>
                                         <p:tgtEl>
-                                          <p:spTgt spid="19"/>
+                                          <p:spTgt spid="18"/>
                                         </p:tgtEl>
                                         <p:attrNameLst>
                                           <p:attrName>style.visibility</p:attrName>
@@ -21489,7 +21010,7 @@
                                       <p:cBhvr>
                                         <p:cTn id="371" dur="550"/>
                                         <p:tgtEl>
-                                          <p:spTgt spid="19"/>
+                                          <p:spTgt spid="18"/>
                                         </p:tgtEl>
                                       </p:cBhvr>
                                     </p:animEffect>
@@ -21510,7 +21031,7 @@
                                           </p:stCondLst>
                                         </p:cTn>
                                         <p:tgtEl>
-                                          <p:spTgt spid="20"/>
+                                          <p:spTgt spid="19"/>
                                         </p:tgtEl>
                                         <p:attrNameLst>
                                           <p:attrName>style.visibility</p:attrName>
@@ -21524,7 +21045,7 @@
                                       <p:cBhvr>
                                         <p:cTn id="375" dur="550"/>
                                         <p:tgtEl>
-                                          <p:spTgt spid="20"/>
+                                          <p:spTgt spid="19"/>
                                         </p:tgtEl>
                                       </p:cBhvr>
                                     </p:animEffect>
@@ -21639,7 +21160,7 @@
                               <p:par>
                                 <p:cTn id="389" presetID="10" presetClass="entr" presetSubtype="0" fill="hold" grpId="0" nodeType="withEffect">
                                   <p:stCondLst>
-                                    <p:cond delay="350"/>
+                                    <p:cond delay="500"/>
                                   </p:stCondLst>
                                   <p:childTnLst>
                                     <p:set>
@@ -21650,7 +21171,7 @@
                                           </p:stCondLst>
                                         </p:cTn>
                                         <p:tgtEl>
-                                          <p:spTgt spid="15"/>
+                                          <p:spTgt spid="20"/>
                                         </p:tgtEl>
                                         <p:attrNameLst>
                                           <p:attrName>style.visibility</p:attrName>
@@ -21664,7 +21185,7 @@
                                       <p:cBhvr>
                                         <p:cTn id="391" dur="550"/>
                                         <p:tgtEl>
-                                          <p:spTgt spid="15"/>
+                                          <p:spTgt spid="20"/>
                                         </p:tgtEl>
                                       </p:cBhvr>
                                     </p:animEffect>
@@ -21744,7 +21265,7 @@
                               <p:par>
                                 <p:cTn id="401" presetID="10" presetClass="entr" presetSubtype="0" fill="hold" grpId="0" nodeType="withEffect">
                                   <p:stCondLst>
-                                    <p:cond delay="500"/>
+                                    <p:cond delay="650"/>
                                   </p:stCondLst>
                                   <p:childTnLst>
                                     <p:set>
@@ -21849,7 +21370,7 @@
                               <p:par>
                                 <p:cTn id="413" presetID="10" presetClass="entr" presetSubtype="0" fill="hold" grpId="0" nodeType="withEffect">
                                   <p:stCondLst>
-                                    <p:cond delay="650"/>
+                                    <p:cond delay="800"/>
                                   </p:stCondLst>
                                   <p:childTnLst>
                                     <p:set>
@@ -21860,7 +21381,7 @@
                                           </p:stCondLst>
                                         </p:cTn>
                                         <p:tgtEl>
-                                          <p:spTgt spid="26"/>
+                                          <p:spTgt spid="32"/>
                                         </p:tgtEl>
                                         <p:attrNameLst>
                                           <p:attrName>style.visibility</p:attrName>
@@ -21874,7 +21395,7 @@
                                       <p:cBhvr>
                                         <p:cTn id="415" dur="550"/>
                                         <p:tgtEl>
-                                          <p:spTgt spid="26"/>
+                                          <p:spTgt spid="32"/>
                                         </p:tgtEl>
                                       </p:cBhvr>
                                     </p:animEffect>
@@ -21884,7 +21405,7 @@
                               <p:par>
                                 <p:cTn id="417" presetID="10" presetClass="entr" presetSubtype="0" fill="hold" grpId="0" nodeType="withEffect">
                                   <p:stCondLst>
-                                    <p:cond delay="650"/>
+                                    <p:cond delay="800"/>
                                   </p:stCondLst>
                                   <p:childTnLst>
                                     <p:set>
@@ -21895,7 +21416,7 @@
                                           </p:stCondLst>
                                         </p:cTn>
                                         <p:tgtEl>
-                                          <p:spTgt spid="27"/>
+                                          <p:spTgt spid="33"/>
                                         </p:tgtEl>
                                         <p:attrNameLst>
                                           <p:attrName>style.visibility</p:attrName>
@@ -21909,7 +21430,7 @@
                                       <p:cBhvr>
                                         <p:cTn id="419" dur="550"/>
                                         <p:tgtEl>
-                                          <p:spTgt spid="27"/>
+                                          <p:spTgt spid="33"/>
                                         </p:tgtEl>
                                       </p:cBhvr>
                                     </p:animEffect>
@@ -21930,7 +21451,7 @@
                                           </p:stCondLst>
                                         </p:cTn>
                                         <p:tgtEl>
-                                          <p:spTgt spid="37"/>
+                                          <p:spTgt spid="34"/>
                                         </p:tgtEl>
                                         <p:attrNameLst>
                                           <p:attrName>style.visibility</p:attrName>
@@ -21944,7 +21465,7 @@
                                       <p:cBhvr>
                                         <p:cTn id="423" dur="550"/>
                                         <p:tgtEl>
-                                          <p:spTgt spid="37"/>
+                                          <p:spTgt spid="34"/>
                                         </p:tgtEl>
                                       </p:cBhvr>
                                     </p:animEffect>
@@ -21954,7 +21475,7 @@
                               <p:par>
                                 <p:cTn id="425" presetID="10" presetClass="entr" presetSubtype="0" fill="hold" grpId="0" nodeType="withEffect">
                                   <p:stCondLst>
-                                    <p:cond delay="800"/>
+                                    <p:cond delay="950"/>
                                   </p:stCondLst>
                                   <p:childTnLst>
                                     <p:set>
@@ -21965,7 +21486,7 @@
                                           </p:stCondLst>
                                         </p:cTn>
                                         <p:tgtEl>
-                                          <p:spTgt spid="38"/>
+                                          <p:spTgt spid="26"/>
                                         </p:tgtEl>
                                         <p:attrNameLst>
                                           <p:attrName>style.visibility</p:attrName>
@@ -21979,7 +21500,7 @@
                                       <p:cBhvr>
                                         <p:cTn id="427" dur="550"/>
                                         <p:tgtEl>
-                                          <p:spTgt spid="38"/>
+                                          <p:spTgt spid="26"/>
                                         </p:tgtEl>
                                       </p:cBhvr>
                                     </p:animEffect>
@@ -21989,7 +21510,7 @@
                               <p:par>
                                 <p:cTn id="429" presetID="10" presetClass="entr" presetSubtype="0" fill="hold" grpId="0" nodeType="withEffect">
                                   <p:stCondLst>
-                                    <p:cond delay="800"/>
+                                    <p:cond delay="950"/>
                                   </p:stCondLst>
                                   <p:childTnLst>
                                     <p:set>
@@ -22000,7 +21521,7 @@
                                           </p:stCondLst>
                                         </p:cTn>
                                         <p:tgtEl>
-                                          <p:spTgt spid="39"/>
+                                          <p:spTgt spid="27"/>
                                         </p:tgtEl>
                                         <p:attrNameLst>
                                           <p:attrName>style.visibility</p:attrName>
@@ -22014,7 +21535,7 @@
                                       <p:cBhvr>
                                         <p:cTn id="431" dur="550"/>
                                         <p:tgtEl>
-                                          <p:spTgt spid="39"/>
+                                          <p:spTgt spid="27"/>
                                         </p:tgtEl>
                                       </p:cBhvr>
                                     </p:animEffect>
@@ -22059,7 +21580,7 @@
                               <p:par>
                                 <p:cTn id="437" presetID="10" presetClass="entr" presetSubtype="0" fill="hold" grpId="0" nodeType="withEffect">
                                   <p:stCondLst>
-                                    <p:cond delay="950"/>
+                                    <p:cond delay="1100"/>
                                   </p:stCondLst>
                                   <p:childTnLst>
                                     <p:set>
@@ -22094,7 +21615,7 @@
                               <p:par>
                                 <p:cTn id="441" presetID="10" presetClass="entr" presetSubtype="0" fill="hold" grpId="0" nodeType="withEffect">
                                   <p:stCondLst>
-                                    <p:cond delay="950"/>
+                                    <p:cond delay="1100"/>
                                   </p:stCondLst>
                                   <p:childTnLst>
                                     <p:set>
@@ -22129,7 +21650,7 @@
                               <p:par>
                                 <p:cTn id="445" presetID="10" presetClass="entr" presetSubtype="0" fill="hold" grpId="0" nodeType="withEffect">
                                   <p:stCondLst>
-                                    <p:cond delay="950"/>
+                                    <p:cond delay="1100"/>
                                   </p:stCondLst>
                                   <p:childTnLst>
                                     <p:set>
@@ -22164,7 +21685,7 @@
                               <p:par>
                                 <p:cTn id="449" presetID="10" presetClass="entr" presetSubtype="0" fill="hold" grpId="0" nodeType="withEffect">
                                   <p:stCondLst>
-                                    <p:cond delay="950"/>
+                                    <p:cond delay="1250"/>
                                   </p:stCondLst>
                                   <p:childTnLst>
                                     <p:set>
@@ -22175,7 +21696,7 @@
                                           </p:stCondLst>
                                         </p:cTn>
                                         <p:tgtEl>
-                                          <p:spTgt spid="32"/>
+                                          <p:spTgt spid="35"/>
                                         </p:tgtEl>
                                         <p:attrNameLst>
                                           <p:attrName>style.visibility</p:attrName>
@@ -22189,7 +21710,7 @@
                                       <p:cBhvr>
                                         <p:cTn id="451" dur="550"/>
                                         <p:tgtEl>
-                                          <p:spTgt spid="32"/>
+                                          <p:spTgt spid="35"/>
                                         </p:tgtEl>
                                       </p:cBhvr>
                                     </p:animEffect>
@@ -22199,7 +21720,7 @@
                               <p:par>
                                 <p:cTn id="453" presetID="10" presetClass="entr" presetSubtype="0" fill="hold" grpId="0" nodeType="withEffect">
                                   <p:stCondLst>
-                                    <p:cond delay="950"/>
+                                    <p:cond delay="1250"/>
                                   </p:stCondLst>
                                   <p:childTnLst>
                                     <p:set>
@@ -22210,7 +21731,7 @@
                                           </p:stCondLst>
                                         </p:cTn>
                                         <p:tgtEl>
-                                          <p:spTgt spid="33"/>
+                                          <p:spTgt spid="36"/>
                                         </p:tgtEl>
                                         <p:attrNameLst>
                                           <p:attrName>style.visibility</p:attrName>
@@ -22224,7 +21745,7 @@
                                       <p:cBhvr>
                                         <p:cTn id="455" dur="550"/>
                                         <p:tgtEl>
-                                          <p:spTgt spid="33"/>
+                                          <p:spTgt spid="36"/>
                                         </p:tgtEl>
                                       </p:cBhvr>
                                     </p:animEffect>
@@ -22234,7 +21755,7 @@
                               <p:par>
                                 <p:cTn id="457" presetID="10" presetClass="entr" presetSubtype="0" fill="hold" grpId="0" nodeType="withEffect">
                                   <p:stCondLst>
-                                    <p:cond delay="1100"/>
+                                    <p:cond delay="1250"/>
                                   </p:stCondLst>
                                   <p:childTnLst>
                                     <p:set>
@@ -22245,7 +21766,7 @@
                                           </p:stCondLst>
                                         </p:cTn>
                                         <p:tgtEl>
-                                          <p:spTgt spid="34"/>
+                                          <p:spTgt spid="37"/>
                                         </p:tgtEl>
                                         <p:attrNameLst>
                                           <p:attrName>style.visibility</p:attrName>
@@ -22259,7 +21780,7 @@
                                       <p:cBhvr>
                                         <p:cTn id="459" dur="550"/>
                                         <p:tgtEl>
-                                          <p:spTgt spid="34"/>
+                                          <p:spTgt spid="37"/>
                                         </p:tgtEl>
                                       </p:cBhvr>
                                     </p:animEffect>
@@ -22269,7 +21790,7 @@
                               <p:par>
                                 <p:cTn id="461" presetID="10" presetClass="entr" presetSubtype="0" fill="hold" grpId="0" nodeType="withEffect">
                                   <p:stCondLst>
-                                    <p:cond delay="1100"/>
+                                    <p:cond delay="1400"/>
                                   </p:stCondLst>
                                   <p:childTnLst>
                                     <p:set>
@@ -22280,7 +21801,7 @@
                                           </p:stCondLst>
                                         </p:cTn>
                                         <p:tgtEl>
-                                          <p:spTgt spid="35"/>
+                                          <p:spTgt spid="38"/>
                                         </p:tgtEl>
                                         <p:attrNameLst>
                                           <p:attrName>style.visibility</p:attrName>
@@ -22294,7 +21815,7 @@
                                       <p:cBhvr>
                                         <p:cTn id="463" dur="550"/>
                                         <p:tgtEl>
-                                          <p:spTgt spid="35"/>
+                                          <p:spTgt spid="38"/>
                                         </p:tgtEl>
                                       </p:cBhvr>
                                     </p:animEffect>
@@ -22304,7 +21825,7 @@
                               <p:par>
                                 <p:cTn id="465" presetID="10" presetClass="entr" presetSubtype="0" fill="hold" grpId="0" nodeType="withEffect">
                                   <p:stCondLst>
-                                    <p:cond delay="1100"/>
+                                    <p:cond delay="1400"/>
                                   </p:stCondLst>
                                   <p:childTnLst>
                                     <p:set>
@@ -22315,7 +21836,7 @@
                                           </p:stCondLst>
                                         </p:cTn>
                                         <p:tgtEl>
-                                          <p:spTgt spid="36"/>
+                                          <p:spTgt spid="39"/>
                                         </p:tgtEl>
                                         <p:attrNameLst>
                                           <p:attrName>style.visibility</p:attrName>
@@ -22329,7 +21850,7 @@
                                       <p:cBhvr>
                                         <p:cTn id="467" dur="550"/>
                                         <p:tgtEl>
-                                          <p:spTgt spid="36"/>
+                                          <p:spTgt spid="39"/>
                                         </p:tgtEl>
                                       </p:cBhvr>
                                     </p:animEffect>
@@ -22339,7 +21860,7 @@
                               <p:par>
                                 <p:cTn id="469" presetID="10" presetClass="entr" presetSubtype="0" fill="hold" grpId="0" nodeType="withEffect">
                                   <p:stCondLst>
-                                    <p:cond delay="1250"/>
+                                    <p:cond delay="1400"/>
                                   </p:stCondLst>
                                   <p:childTnLst>
                                     <p:set>
@@ -22374,7 +21895,7 @@
                               <p:par>
                                 <p:cTn id="473" presetID="10" presetClass="entr" presetSubtype="0" fill="hold" grpId="0" nodeType="withEffect">
                                   <p:stCondLst>
-                                    <p:cond delay="1250"/>
+                                    <p:cond delay="1550"/>
                                   </p:stCondLst>
                                   <p:childTnLst>
                                     <p:set>
@@ -22385,7 +21906,7 @@
                                           </p:stCondLst>
                                         </p:cTn>
                                         <p:tgtEl>
-                                          <p:spTgt spid="41"/>
+                                          <p:spTgt spid="50"/>
                                         </p:tgtEl>
                                         <p:attrNameLst>
                                           <p:attrName>style.visibility</p:attrName>
@@ -22399,7 +21920,7 @@
                                       <p:cBhvr>
                                         <p:cTn id="475" dur="550"/>
                                         <p:tgtEl>
-                                          <p:spTgt spid="41"/>
+                                          <p:spTgt spid="50"/>
                                         </p:tgtEl>
                                       </p:cBhvr>
                                     </p:animEffect>
@@ -22409,7 +21930,7 @@
                               <p:par>
                                 <p:cTn id="477" presetID="10" presetClass="entr" presetSubtype="0" fill="hold" grpId="0" nodeType="withEffect">
                                   <p:stCondLst>
-                                    <p:cond delay="1250"/>
+                                    <p:cond delay="1550"/>
                                   </p:stCondLst>
                                   <p:childTnLst>
                                     <p:set>
@@ -22420,7 +21941,7 @@
                                           </p:stCondLst>
                                         </p:cTn>
                                         <p:tgtEl>
-                                          <p:spTgt spid="42"/>
+                                          <p:spTgt spid="51"/>
                                         </p:tgtEl>
                                         <p:attrNameLst>
                                           <p:attrName>style.visibility</p:attrName>
@@ -22434,7 +21955,7 @@
                                       <p:cBhvr>
                                         <p:cTn id="479" dur="550"/>
                                         <p:tgtEl>
-                                          <p:spTgt spid="42"/>
+                                          <p:spTgt spid="51"/>
                                         </p:tgtEl>
                                       </p:cBhvr>
                                     </p:animEffect>
@@ -22444,7 +21965,7 @@
                               <p:par>
                                 <p:cTn id="481" presetID="10" presetClass="entr" presetSubtype="0" fill="hold" grpId="0" nodeType="withEffect">
                                   <p:stCondLst>
-                                    <p:cond delay="1250"/>
+                                    <p:cond delay="1550"/>
                                   </p:stCondLst>
                                   <p:childTnLst>
                                     <p:set>
@@ -22455,7 +21976,7 @@
                                           </p:stCondLst>
                                         </p:cTn>
                                         <p:tgtEl>
-                                          <p:spTgt spid="43"/>
+                                          <p:spTgt spid="52"/>
                                         </p:tgtEl>
                                         <p:attrNameLst>
                                           <p:attrName>style.visibility</p:attrName>
@@ -22469,7 +21990,7 @@
                                       <p:cBhvr>
                                         <p:cTn id="483" dur="550"/>
                                         <p:tgtEl>
-                                          <p:spTgt spid="43"/>
+                                          <p:spTgt spid="52"/>
                                         </p:tgtEl>
                                       </p:cBhvr>
                                     </p:animEffect>
@@ -22479,7 +22000,7 @@
                               <p:par>
                                 <p:cTn id="485" presetID="10" presetClass="entr" presetSubtype="0" fill="hold" grpId="0" nodeType="withEffect">
                                   <p:stCondLst>
-                                    <p:cond delay="1250"/>
+                                    <p:cond delay="1700"/>
                                   </p:stCondLst>
                                   <p:childTnLst>
                                     <p:set>
@@ -22490,7 +22011,7 @@
                                           </p:stCondLst>
                                         </p:cTn>
                                         <p:tgtEl>
-                                          <p:spTgt spid="44"/>
+                                          <p:spTgt spid="41"/>
                                         </p:tgtEl>
                                         <p:attrNameLst>
                                           <p:attrName>style.visibility</p:attrName>
@@ -22504,7 +22025,7 @@
                                       <p:cBhvr>
                                         <p:cTn id="487" dur="550"/>
                                         <p:tgtEl>
-                                          <p:spTgt spid="44"/>
+                                          <p:spTgt spid="41"/>
                                         </p:tgtEl>
                                       </p:cBhvr>
                                     </p:animEffect>
@@ -22514,7 +22035,7 @@
                               <p:par>
                                 <p:cTn id="489" presetID="10" presetClass="entr" presetSubtype="0" fill="hold" grpId="0" nodeType="withEffect">
                                   <p:stCondLst>
-                                    <p:cond delay="1250"/>
+                                    <p:cond delay="1700"/>
                                   </p:stCondLst>
                                   <p:childTnLst>
                                     <p:set>
@@ -22525,7 +22046,7 @@
                                           </p:stCondLst>
                                         </p:cTn>
                                         <p:tgtEl>
-                                          <p:spTgt spid="45"/>
+                                          <p:spTgt spid="42"/>
                                         </p:tgtEl>
                                         <p:attrNameLst>
                                           <p:attrName>style.visibility</p:attrName>
@@ -22539,7 +22060,7 @@
                                       <p:cBhvr>
                                         <p:cTn id="491" dur="550"/>
                                         <p:tgtEl>
-                                          <p:spTgt spid="45"/>
+                                          <p:spTgt spid="42"/>
                                         </p:tgtEl>
                                       </p:cBhvr>
                                     </p:animEffect>
@@ -22549,7 +22070,7 @@
                               <p:par>
                                 <p:cTn id="493" presetID="10" presetClass="entr" presetSubtype="0" fill="hold" grpId="0" nodeType="withEffect">
                                   <p:stCondLst>
-                                    <p:cond delay="1250"/>
+                                    <p:cond delay="1700"/>
                                   </p:stCondLst>
                                   <p:childTnLst>
                                     <p:set>
@@ -22560,7 +22081,7 @@
                                           </p:stCondLst>
                                         </p:cTn>
                                         <p:tgtEl>
-                                          <p:spTgt spid="46"/>
+                                          <p:spTgt spid="43"/>
                                         </p:tgtEl>
                                         <p:attrNameLst>
                                           <p:attrName>style.visibility</p:attrName>
@@ -22574,7 +22095,7 @@
                                       <p:cBhvr>
                                         <p:cTn id="495" dur="550"/>
                                         <p:tgtEl>
-                                          <p:spTgt spid="46"/>
+                                          <p:spTgt spid="43"/>
                                         </p:tgtEl>
                                       </p:cBhvr>
                                     </p:animEffect>
@@ -22584,7 +22105,7 @@
                               <p:par>
                                 <p:cTn id="497" presetID="10" presetClass="entr" presetSubtype="0" fill="hold" grpId="0" nodeType="withEffect">
                                   <p:stCondLst>
-                                    <p:cond delay="1400"/>
+                                    <p:cond delay="1850"/>
                                   </p:stCondLst>
                                   <p:childTnLst>
                                     <p:set>
@@ -22595,7 +22116,7 @@
                                           </p:stCondLst>
                                         </p:cTn>
                                         <p:tgtEl>
-                                          <p:spTgt spid="47"/>
+                                          <p:spTgt spid="44"/>
                                         </p:tgtEl>
                                         <p:attrNameLst>
                                           <p:attrName>style.visibility</p:attrName>
@@ -22609,7 +22130,7 @@
                                       <p:cBhvr>
                                         <p:cTn id="499" dur="550"/>
                                         <p:tgtEl>
-                                          <p:spTgt spid="47"/>
+                                          <p:spTgt spid="44"/>
                                         </p:tgtEl>
                                       </p:cBhvr>
                                     </p:animEffect>
@@ -22619,7 +22140,7 @@
                               <p:par>
                                 <p:cTn id="501" presetID="10" presetClass="entr" presetSubtype="0" fill="hold" grpId="0" nodeType="withEffect">
                                   <p:stCondLst>
-                                    <p:cond delay="1400"/>
+                                    <p:cond delay="1850"/>
                                   </p:stCondLst>
                                   <p:childTnLst>
                                     <p:set>
@@ -22630,7 +22151,7 @@
                                           </p:stCondLst>
                                         </p:cTn>
                                         <p:tgtEl>
-                                          <p:spTgt spid="48"/>
+                                          <p:spTgt spid="45"/>
                                         </p:tgtEl>
                                         <p:attrNameLst>
                                           <p:attrName>style.visibility</p:attrName>
@@ -22644,7 +22165,7 @@
                                       <p:cBhvr>
                                         <p:cTn id="503" dur="550"/>
                                         <p:tgtEl>
-                                          <p:spTgt spid="48"/>
+                                          <p:spTgt spid="45"/>
                                         </p:tgtEl>
                                       </p:cBhvr>
                                     </p:animEffect>
@@ -22654,7 +22175,7 @@
                               <p:par>
                                 <p:cTn id="505" presetID="10" presetClass="entr" presetSubtype="0" fill="hold" grpId="0" nodeType="withEffect">
                                   <p:stCondLst>
-                                    <p:cond delay="1400"/>
+                                    <p:cond delay="1850"/>
                                   </p:stCondLst>
                                   <p:childTnLst>
                                     <p:set>
@@ -22665,7 +22186,7 @@
                                           </p:stCondLst>
                                         </p:cTn>
                                         <p:tgtEl>
-                                          <p:spTgt spid="49"/>
+                                          <p:spTgt spid="46"/>
                                         </p:tgtEl>
                                         <p:attrNameLst>
                                           <p:attrName>style.visibility</p:attrName>
@@ -22679,7 +22200,7 @@
                                       <p:cBhvr>
                                         <p:cTn id="507" dur="550"/>
                                         <p:tgtEl>
-                                          <p:spTgt spid="49"/>
+                                          <p:spTgt spid="46"/>
                                         </p:tgtEl>
                                       </p:cBhvr>
                                     </p:animEffect>
@@ -22689,7 +22210,7 @@
                               <p:par>
                                 <p:cTn id="509" presetID="10" presetClass="entr" presetSubtype="0" fill="hold" grpId="0" nodeType="withEffect">
                                   <p:stCondLst>
-                                    <p:cond delay="1550"/>
+                                    <p:cond delay="2000"/>
                                   </p:stCondLst>
                                   <p:childTnLst>
                                     <p:set>
@@ -22700,7 +22221,7 @@
                                           </p:stCondLst>
                                         </p:cTn>
                                         <p:tgtEl>
-                                          <p:spTgt spid="61"/>
+                                          <p:spTgt spid="47"/>
                                         </p:tgtEl>
                                         <p:attrNameLst>
                                           <p:attrName>style.visibility</p:attrName>
@@ -22714,7 +22235,7 @@
                                       <p:cBhvr>
                                         <p:cTn id="511" dur="550"/>
                                         <p:tgtEl>
-                                          <p:spTgt spid="61"/>
+                                          <p:spTgt spid="47"/>
                                         </p:tgtEl>
                                       </p:cBhvr>
                                     </p:animEffect>
@@ -22724,7 +22245,7 @@
                               <p:par>
                                 <p:cTn id="513" presetID="10" presetClass="entr" presetSubtype="0" fill="hold" grpId="0" nodeType="withEffect">
                                   <p:stCondLst>
-                                    <p:cond delay="1550"/>
+                                    <p:cond delay="2000"/>
                                   </p:stCondLst>
                                   <p:childTnLst>
                                     <p:set>
@@ -22735,7 +22256,7 @@
                                           </p:stCondLst>
                                         </p:cTn>
                                         <p:tgtEl>
-                                          <p:spTgt spid="62"/>
+                                          <p:spTgt spid="48"/>
                                         </p:tgtEl>
                                         <p:attrNameLst>
                                           <p:attrName>style.visibility</p:attrName>
@@ -22749,7 +22270,7 @@
                                       <p:cBhvr>
                                         <p:cTn id="515" dur="550"/>
                                         <p:tgtEl>
-                                          <p:spTgt spid="62"/>
+                                          <p:spTgt spid="48"/>
                                         </p:tgtEl>
                                       </p:cBhvr>
                                     </p:animEffect>
@@ -22759,7 +22280,7 @@
                               <p:par>
                                 <p:cTn id="517" presetID="10" presetClass="entr" presetSubtype="0" fill="hold" grpId="0" nodeType="withEffect">
                                   <p:stCondLst>
-                                    <p:cond delay="1550"/>
+                                    <p:cond delay="2000"/>
                                   </p:stCondLst>
                                   <p:childTnLst>
                                     <p:set>
@@ -22770,7 +22291,7 @@
                                           </p:stCondLst>
                                         </p:cTn>
                                         <p:tgtEl>
-                                          <p:spTgt spid="63"/>
+                                          <p:spTgt spid="49"/>
                                         </p:tgtEl>
                                         <p:attrNameLst>
                                           <p:attrName>style.visibility</p:attrName>
@@ -22784,7 +22305,7 @@
                                       <p:cBhvr>
                                         <p:cTn id="519" dur="550"/>
                                         <p:tgtEl>
-                                          <p:spTgt spid="63"/>
+                                          <p:spTgt spid="49"/>
                                         </p:tgtEl>
                                       </p:cBhvr>
                                     </p:animEffect>
@@ -22794,7 +22315,7 @@
                               <p:par>
                                 <p:cTn id="521" presetID="10" presetClass="entr" presetSubtype="0" fill="hold" grpId="0" nodeType="withEffect">
                                   <p:stCondLst>
-                                    <p:cond delay="1550"/>
+                                    <p:cond delay="300"/>
                                   </p:stCondLst>
                                   <p:childTnLst>
                                     <p:set>
@@ -22805,7 +22326,7 @@
                                           </p:stCondLst>
                                         </p:cTn>
                                         <p:tgtEl>
-                                          <p:spTgt spid="64"/>
+                                          <p:spTgt spid="53"/>
                                         </p:tgtEl>
                                         <p:attrNameLst>
                                           <p:attrName>style.visibility</p:attrName>
@@ -22819,7 +22340,7 @@
                                       <p:cBhvr>
                                         <p:cTn id="523" dur="550"/>
                                         <p:tgtEl>
-                                          <p:spTgt spid="64"/>
+                                          <p:spTgt spid="53"/>
                                         </p:tgtEl>
                                       </p:cBhvr>
                                     </p:animEffect>
@@ -22829,7 +22350,7 @@
                               <p:par>
                                 <p:cTn id="525" presetID="10" presetClass="entr" presetSubtype="0" fill="hold" grpId="0" nodeType="withEffect">
                                   <p:stCondLst>
-                                    <p:cond delay="1550"/>
+                                    <p:cond delay="420"/>
                                   </p:stCondLst>
                                   <p:childTnLst>
                                     <p:set>
@@ -22840,7 +22361,7 @@
                                           </p:stCondLst>
                                         </p:cTn>
                                         <p:tgtEl>
-                                          <p:spTgt spid="65"/>
+                                          <p:spTgt spid="54"/>
                                         </p:tgtEl>
                                         <p:attrNameLst>
                                           <p:attrName>style.visibility</p:attrName>
@@ -22854,7 +22375,7 @@
                                       <p:cBhvr>
                                         <p:cTn id="527" dur="550"/>
                                         <p:tgtEl>
-                                          <p:spTgt spid="65"/>
+                                          <p:spTgt spid="54"/>
                                         </p:tgtEl>
                                       </p:cBhvr>
                                     </p:animEffect>
@@ -22864,7 +22385,7 @@
                               <p:par>
                                 <p:cTn id="529" presetID="10" presetClass="entr" presetSubtype="0" fill="hold" grpId="0" nodeType="withEffect">
                                   <p:stCondLst>
-                                    <p:cond delay="1700"/>
+                                    <p:cond delay="540"/>
                                   </p:stCondLst>
                                   <p:childTnLst>
                                     <p:set>
@@ -22875,7 +22396,7 @@
                                           </p:stCondLst>
                                         </p:cTn>
                                         <p:tgtEl>
-                                          <p:spTgt spid="50"/>
+                                          <p:spTgt spid="55"/>
                                         </p:tgtEl>
                                         <p:attrNameLst>
                                           <p:attrName>style.visibility</p:attrName>
@@ -22889,7 +22410,7 @@
                                       <p:cBhvr>
                                         <p:cTn id="531" dur="550"/>
                                         <p:tgtEl>
-                                          <p:spTgt spid="50"/>
+                                          <p:spTgt spid="55"/>
                                         </p:tgtEl>
                                       </p:cBhvr>
                                     </p:animEffect>
@@ -22899,7 +22420,7 @@
                               <p:par>
                                 <p:cTn id="533" presetID="10" presetClass="entr" presetSubtype="0" fill="hold" grpId="0" nodeType="withEffect">
                                   <p:stCondLst>
-                                    <p:cond delay="1700"/>
+                                    <p:cond delay="660"/>
                                   </p:stCondLst>
                                   <p:childTnLst>
                                     <p:set>
@@ -22910,7 +22431,7 @@
                                           </p:stCondLst>
                                         </p:cTn>
                                         <p:tgtEl>
-                                          <p:spTgt spid="51"/>
+                                          <p:spTgt spid="56"/>
                                         </p:tgtEl>
                                         <p:attrNameLst>
                                           <p:attrName>style.visibility</p:attrName>
@@ -22924,7 +22445,7 @@
                                       <p:cBhvr>
                                         <p:cTn id="535" dur="550"/>
                                         <p:tgtEl>
-                                          <p:spTgt spid="51"/>
+                                          <p:spTgt spid="56"/>
                                         </p:tgtEl>
                                       </p:cBhvr>
                                     </p:animEffect>
@@ -22934,7 +22455,7 @@
                               <p:par>
                                 <p:cTn id="537" presetID="10" presetClass="entr" presetSubtype="0" fill="hold" grpId="0" nodeType="withEffect">
                                   <p:stCondLst>
-                                    <p:cond delay="1700"/>
+                                    <p:cond delay="780"/>
                                   </p:stCondLst>
                                   <p:childTnLst>
                                     <p:set>
@@ -22945,7 +22466,7 @@
                                           </p:stCondLst>
                                         </p:cTn>
                                         <p:tgtEl>
-                                          <p:spTgt spid="52"/>
+                                          <p:spTgt spid="57"/>
                                         </p:tgtEl>
                                         <p:attrNameLst>
                                           <p:attrName>style.visibility</p:attrName>
@@ -22959,7 +22480,7 @@
                                       <p:cBhvr>
                                         <p:cTn id="539" dur="550"/>
                                         <p:tgtEl>
-                                          <p:spTgt spid="52"/>
+                                          <p:spTgt spid="57"/>
                                         </p:tgtEl>
                                       </p:cBhvr>
                                     </p:animEffect>
@@ -22969,7 +22490,7 @@
                               <p:par>
                                 <p:cTn id="541" presetID="10" presetClass="entr" presetSubtype="0" fill="hold" grpId="0" nodeType="withEffect">
                                   <p:stCondLst>
-                                    <p:cond delay="1700"/>
+                                    <p:cond delay="900"/>
                                   </p:stCondLst>
                                   <p:childTnLst>
                                     <p:set>
@@ -22980,7 +22501,7 @@
                                           </p:stCondLst>
                                         </p:cTn>
                                         <p:tgtEl>
-                                          <p:spTgt spid="53"/>
+                                          <p:spTgt spid="58"/>
                                         </p:tgtEl>
                                         <p:attrNameLst>
                                           <p:attrName>style.visibility</p:attrName>
@@ -22994,7 +22515,7 @@
                                       <p:cBhvr>
                                         <p:cTn id="543" dur="550"/>
                                         <p:tgtEl>
-                                          <p:spTgt spid="53"/>
+                                          <p:spTgt spid="58"/>
                                         </p:tgtEl>
                                       </p:cBhvr>
                                     </p:animEffect>
@@ -23004,7 +22525,7 @@
                               <p:par>
                                 <p:cTn id="545" presetID="10" presetClass="entr" presetSubtype="0" fill="hold" grpId="0" nodeType="withEffect">
                                   <p:stCondLst>
-                                    <p:cond delay="1850"/>
+                                    <p:cond delay="1020"/>
                                   </p:stCondLst>
                                   <p:childTnLst>
                                     <p:set>
@@ -23015,7 +22536,7 @@
                                           </p:stCondLst>
                                         </p:cTn>
                                         <p:tgtEl>
-                                          <p:spTgt spid="54"/>
+                                          <p:spTgt spid="59"/>
                                         </p:tgtEl>
                                         <p:attrNameLst>
                                           <p:attrName>style.visibility</p:attrName>
@@ -23029,7 +22550,7 @@
                                       <p:cBhvr>
                                         <p:cTn id="547" dur="550"/>
                                         <p:tgtEl>
-                                          <p:spTgt spid="54"/>
+                                          <p:spTgt spid="59"/>
                                         </p:tgtEl>
                                       </p:cBhvr>
                                     </p:animEffect>
@@ -23039,7 +22560,7 @@
                               <p:par>
                                 <p:cTn id="549" presetID="10" presetClass="entr" presetSubtype="0" fill="hold" grpId="0" nodeType="withEffect">
                                   <p:stCondLst>
-                                    <p:cond delay="1850"/>
+                                    <p:cond delay="1140"/>
                                   </p:stCondLst>
                                   <p:childTnLst>
                                     <p:set>
@@ -23050,7 +22571,7 @@
                                           </p:stCondLst>
                                         </p:cTn>
                                         <p:tgtEl>
-                                          <p:spTgt spid="55"/>
+                                          <p:spTgt spid="60"/>
                                         </p:tgtEl>
                                         <p:attrNameLst>
                                           <p:attrName>style.visibility</p:attrName>
@@ -23064,7 +22585,7 @@
                                       <p:cBhvr>
                                         <p:cTn id="551" dur="550"/>
                                         <p:tgtEl>
-                                          <p:spTgt spid="55"/>
+                                          <p:spTgt spid="60"/>
                                         </p:tgtEl>
                                       </p:cBhvr>
                                     </p:animEffect>
@@ -23074,7 +22595,7 @@
                               <p:par>
                                 <p:cTn id="553" presetID="10" presetClass="entr" presetSubtype="0" fill="hold" grpId="0" nodeType="withEffect">
                                   <p:stCondLst>
-                                    <p:cond delay="1850"/>
+                                    <p:cond delay="1260"/>
                                   </p:stCondLst>
                                   <p:childTnLst>
                                     <p:set>
@@ -23085,7 +22606,7 @@
                                           </p:stCondLst>
                                         </p:cTn>
                                         <p:tgtEl>
-                                          <p:spTgt spid="56"/>
+                                          <p:spTgt spid="61"/>
                                         </p:tgtEl>
                                         <p:attrNameLst>
                                           <p:attrName>style.visibility</p:attrName>
@@ -23099,7 +22620,7 @@
                                       <p:cBhvr>
                                         <p:cTn id="555" dur="550"/>
                                         <p:tgtEl>
-                                          <p:spTgt spid="56"/>
+                                          <p:spTgt spid="61"/>
                                         </p:tgtEl>
                                       </p:cBhvr>
                                     </p:animEffect>
@@ -23109,7 +22630,7 @@
                               <p:par>
                                 <p:cTn id="557" presetID="10" presetClass="entr" presetSubtype="0" fill="hold" grpId="0" nodeType="withEffect">
                                   <p:stCondLst>
-                                    <p:cond delay="1850"/>
+                                    <p:cond delay="1380"/>
                                   </p:stCondLst>
                                   <p:childTnLst>
                                     <p:set>
@@ -23120,7 +22641,7 @@
                                           </p:stCondLst>
                                         </p:cTn>
                                         <p:tgtEl>
-                                          <p:spTgt spid="57"/>
+                                          <p:spTgt spid="62"/>
                                         </p:tgtEl>
                                         <p:attrNameLst>
                                           <p:attrName>style.visibility</p:attrName>
@@ -23134,7 +22655,7 @@
                                       <p:cBhvr>
                                         <p:cTn id="559" dur="550"/>
                                         <p:tgtEl>
-                                          <p:spTgt spid="57"/>
+                                          <p:spTgt spid="62"/>
                                         </p:tgtEl>
                                       </p:cBhvr>
                                     </p:animEffect>
@@ -23144,7 +22665,7 @@
                               <p:par>
                                 <p:cTn id="561" presetID="10" presetClass="entr" presetSubtype="0" fill="hold" grpId="0" nodeType="withEffect">
                                   <p:stCondLst>
-                                    <p:cond delay="2000"/>
+                                    <p:cond delay="1500"/>
                                   </p:stCondLst>
                                   <p:childTnLst>
                                     <p:set>
@@ -23155,7 +22676,7 @@
                                           </p:stCondLst>
                                         </p:cTn>
                                         <p:tgtEl>
-                                          <p:spTgt spid="58"/>
+                                          <p:spTgt spid="63"/>
                                         </p:tgtEl>
                                         <p:attrNameLst>
                                           <p:attrName>style.visibility</p:attrName>
@@ -23169,7 +22690,7 @@
                                       <p:cBhvr>
                                         <p:cTn id="563" dur="550"/>
                                         <p:tgtEl>
-                                          <p:spTgt spid="58"/>
+                                          <p:spTgt spid="63"/>
                                         </p:tgtEl>
                                       </p:cBhvr>
                                     </p:animEffect>
@@ -23179,7 +22700,7 @@
                               <p:par>
                                 <p:cTn id="565" presetID="10" presetClass="entr" presetSubtype="0" fill="hold" grpId="0" nodeType="withEffect">
                                   <p:stCondLst>
-                                    <p:cond delay="2000"/>
+                                    <p:cond delay="1620"/>
                                   </p:stCondLst>
                                   <p:childTnLst>
                                     <p:set>
@@ -23190,7 +22711,7 @@
                                           </p:stCondLst>
                                         </p:cTn>
                                         <p:tgtEl>
-                                          <p:spTgt spid="59"/>
+                                          <p:spTgt spid="64"/>
                                         </p:tgtEl>
                                         <p:attrNameLst>
                                           <p:attrName>style.visibility</p:attrName>
@@ -23204,462 +22725,7 @@
                                       <p:cBhvr>
                                         <p:cTn id="567" dur="550"/>
                                         <p:tgtEl>
-                                          <p:spTgt spid="59"/>
-                                        </p:tgtEl>
-                                      </p:cBhvr>
-                                    </p:animEffect>
-                                  </p:childTnLst>
-                                </p:cTn>
-                              </p:par>
-                              <p:par>
-                                <p:cTn id="569" presetID="10" presetClass="entr" presetSubtype="0" fill="hold" grpId="0" nodeType="withEffect">
-                                  <p:stCondLst>
-                                    <p:cond delay="2000"/>
-                                  </p:stCondLst>
-                                  <p:childTnLst>
-                                    <p:set>
-                                      <p:cBhvr>
-                                        <p:cTn id="570" dur="1" fill="hold">
-                                          <p:stCondLst>
-                                            <p:cond delay="0"/>
-                                          </p:stCondLst>
-                                        </p:cTn>
-                                        <p:tgtEl>
-                                          <p:spTgt spid="60"/>
-                                        </p:tgtEl>
-                                        <p:attrNameLst>
-                                          <p:attrName>style.visibility</p:attrName>
-                                        </p:attrNameLst>
-                                      </p:cBhvr>
-                                      <p:to>
-                                        <p:strVal val="visible"/>
-                                      </p:to>
-                                    </p:set>
-                                    <p:animEffect transition="in" filter="fade">
-                                      <p:cBhvr>
-                                        <p:cTn id="571" dur="550"/>
-                                        <p:tgtEl>
-                                          <p:spTgt spid="60"/>
-                                        </p:tgtEl>
-                                      </p:cBhvr>
-                                    </p:animEffect>
-                                  </p:childTnLst>
-                                </p:cTn>
-                              </p:par>
-                              <p:par>
-                                <p:cTn id="573" presetID="10" presetClass="entr" presetSubtype="0" fill="hold" grpId="0" nodeType="withEffect">
-                                  <p:stCondLst>
-                                    <p:cond delay="300"/>
-                                  </p:stCondLst>
-                                  <p:childTnLst>
-                                    <p:set>
-                                      <p:cBhvr>
-                                        <p:cTn id="574" dur="1" fill="hold">
-                                          <p:stCondLst>
-                                            <p:cond delay="0"/>
-                                          </p:stCondLst>
-                                        </p:cTn>
-                                        <p:tgtEl>
-                                          <p:spTgt spid="66"/>
-                                        </p:tgtEl>
-                                        <p:attrNameLst>
-                                          <p:attrName>style.visibility</p:attrName>
-                                        </p:attrNameLst>
-                                      </p:cBhvr>
-                                      <p:to>
-                                        <p:strVal val="visible"/>
-                                      </p:to>
-                                    </p:set>
-                                    <p:animEffect transition="in" filter="fade">
-                                      <p:cBhvr>
-                                        <p:cTn id="575" dur="550"/>
-                                        <p:tgtEl>
-                                          <p:spTgt spid="66"/>
-                                        </p:tgtEl>
-                                      </p:cBhvr>
-                                    </p:animEffect>
-                                  </p:childTnLst>
-                                </p:cTn>
-                              </p:par>
-                              <p:par>
-                                <p:cTn id="577" presetID="10" presetClass="entr" presetSubtype="0" fill="hold" grpId="0" nodeType="withEffect">
-                                  <p:stCondLst>
-                                    <p:cond delay="420"/>
-                                  </p:stCondLst>
-                                  <p:childTnLst>
-                                    <p:set>
-                                      <p:cBhvr>
-                                        <p:cTn id="578" dur="1" fill="hold">
-                                          <p:stCondLst>
-                                            <p:cond delay="0"/>
-                                          </p:stCondLst>
-                                        </p:cTn>
-                                        <p:tgtEl>
-                                          <p:spTgt spid="67"/>
-                                        </p:tgtEl>
-                                        <p:attrNameLst>
-                                          <p:attrName>style.visibility</p:attrName>
-                                        </p:attrNameLst>
-                                      </p:cBhvr>
-                                      <p:to>
-                                        <p:strVal val="visible"/>
-                                      </p:to>
-                                    </p:set>
-                                    <p:animEffect transition="in" filter="fade">
-                                      <p:cBhvr>
-                                        <p:cTn id="579" dur="550"/>
-                                        <p:tgtEl>
-                                          <p:spTgt spid="67"/>
-                                        </p:tgtEl>
-                                      </p:cBhvr>
-                                    </p:animEffect>
-                                  </p:childTnLst>
-                                </p:cTn>
-                              </p:par>
-                              <p:par>
-                                <p:cTn id="581" presetID="10" presetClass="entr" presetSubtype="0" fill="hold" grpId="0" nodeType="withEffect">
-                                  <p:stCondLst>
-                                    <p:cond delay="540"/>
-                                  </p:stCondLst>
-                                  <p:childTnLst>
-                                    <p:set>
-                                      <p:cBhvr>
-                                        <p:cTn id="582" dur="1" fill="hold">
-                                          <p:stCondLst>
-                                            <p:cond delay="0"/>
-                                          </p:stCondLst>
-                                        </p:cTn>
-                                        <p:tgtEl>
-                                          <p:spTgt spid="68"/>
-                                        </p:tgtEl>
-                                        <p:attrNameLst>
-                                          <p:attrName>style.visibility</p:attrName>
-                                        </p:attrNameLst>
-                                      </p:cBhvr>
-                                      <p:to>
-                                        <p:strVal val="visible"/>
-                                      </p:to>
-                                    </p:set>
-                                    <p:animEffect transition="in" filter="fade">
-                                      <p:cBhvr>
-                                        <p:cTn id="583" dur="550"/>
-                                        <p:tgtEl>
-                                          <p:spTgt spid="68"/>
-                                        </p:tgtEl>
-                                      </p:cBhvr>
-                                    </p:animEffect>
-                                  </p:childTnLst>
-                                </p:cTn>
-                              </p:par>
-                              <p:par>
-                                <p:cTn id="585" presetID="10" presetClass="entr" presetSubtype="0" fill="hold" grpId="0" nodeType="withEffect">
-                                  <p:stCondLst>
-                                    <p:cond delay="660"/>
-                                  </p:stCondLst>
-                                  <p:childTnLst>
-                                    <p:set>
-                                      <p:cBhvr>
-                                        <p:cTn id="586" dur="1" fill="hold">
-                                          <p:stCondLst>
-                                            <p:cond delay="0"/>
-                                          </p:stCondLst>
-                                        </p:cTn>
-                                        <p:tgtEl>
-                                          <p:spTgt spid="69"/>
-                                        </p:tgtEl>
-                                        <p:attrNameLst>
-                                          <p:attrName>style.visibility</p:attrName>
-                                        </p:attrNameLst>
-                                      </p:cBhvr>
-                                      <p:to>
-                                        <p:strVal val="visible"/>
-                                      </p:to>
-                                    </p:set>
-                                    <p:animEffect transition="in" filter="fade">
-                                      <p:cBhvr>
-                                        <p:cTn id="587" dur="550"/>
-                                        <p:tgtEl>
-                                          <p:spTgt spid="69"/>
-                                        </p:tgtEl>
-                                      </p:cBhvr>
-                                    </p:animEffect>
-                                  </p:childTnLst>
-                                </p:cTn>
-                              </p:par>
-                              <p:par>
-                                <p:cTn id="589" presetID="10" presetClass="entr" presetSubtype="0" fill="hold" grpId="0" nodeType="withEffect">
-                                  <p:stCondLst>
-                                    <p:cond delay="780"/>
-                                  </p:stCondLst>
-                                  <p:childTnLst>
-                                    <p:set>
-                                      <p:cBhvr>
-                                        <p:cTn id="590" dur="1" fill="hold">
-                                          <p:stCondLst>
-                                            <p:cond delay="0"/>
-                                          </p:stCondLst>
-                                        </p:cTn>
-                                        <p:tgtEl>
-                                          <p:spTgt spid="70"/>
-                                        </p:tgtEl>
-                                        <p:attrNameLst>
-                                          <p:attrName>style.visibility</p:attrName>
-                                        </p:attrNameLst>
-                                      </p:cBhvr>
-                                      <p:to>
-                                        <p:strVal val="visible"/>
-                                      </p:to>
-                                    </p:set>
-                                    <p:animEffect transition="in" filter="fade">
-                                      <p:cBhvr>
-                                        <p:cTn id="591" dur="550"/>
-                                        <p:tgtEl>
-                                          <p:spTgt spid="70"/>
-                                        </p:tgtEl>
-                                      </p:cBhvr>
-                                    </p:animEffect>
-                                  </p:childTnLst>
-                                </p:cTn>
-                              </p:par>
-                              <p:par>
-                                <p:cTn id="593" presetID="10" presetClass="entr" presetSubtype="0" fill="hold" grpId="0" nodeType="withEffect">
-                                  <p:stCondLst>
-                                    <p:cond delay="900"/>
-                                  </p:stCondLst>
-                                  <p:childTnLst>
-                                    <p:set>
-                                      <p:cBhvr>
-                                        <p:cTn id="594" dur="1" fill="hold">
-                                          <p:stCondLst>
-                                            <p:cond delay="0"/>
-                                          </p:stCondLst>
-                                        </p:cTn>
-                                        <p:tgtEl>
-                                          <p:spTgt spid="71"/>
-                                        </p:tgtEl>
-                                        <p:attrNameLst>
-                                          <p:attrName>style.visibility</p:attrName>
-                                        </p:attrNameLst>
-                                      </p:cBhvr>
-                                      <p:to>
-                                        <p:strVal val="visible"/>
-                                      </p:to>
-                                    </p:set>
-                                    <p:animEffect transition="in" filter="fade">
-                                      <p:cBhvr>
-                                        <p:cTn id="595" dur="550"/>
-                                        <p:tgtEl>
-                                          <p:spTgt spid="71"/>
-                                        </p:tgtEl>
-                                      </p:cBhvr>
-                                    </p:animEffect>
-                                  </p:childTnLst>
-                                </p:cTn>
-                              </p:par>
-                              <p:par>
-                                <p:cTn id="597" presetID="10" presetClass="entr" presetSubtype="0" fill="hold" grpId="0" nodeType="withEffect">
-                                  <p:stCondLst>
-                                    <p:cond delay="1020"/>
-                                  </p:stCondLst>
-                                  <p:childTnLst>
-                                    <p:set>
-                                      <p:cBhvr>
-                                        <p:cTn id="598" dur="1" fill="hold">
-                                          <p:stCondLst>
-                                            <p:cond delay="0"/>
-                                          </p:stCondLst>
-                                        </p:cTn>
-                                        <p:tgtEl>
-                                          <p:spTgt spid="72"/>
-                                        </p:tgtEl>
-                                        <p:attrNameLst>
-                                          <p:attrName>style.visibility</p:attrName>
-                                        </p:attrNameLst>
-                                      </p:cBhvr>
-                                      <p:to>
-                                        <p:strVal val="visible"/>
-                                      </p:to>
-                                    </p:set>
-                                    <p:animEffect transition="in" filter="fade">
-                                      <p:cBhvr>
-                                        <p:cTn id="599" dur="550"/>
-                                        <p:tgtEl>
-                                          <p:spTgt spid="72"/>
-                                        </p:tgtEl>
-                                      </p:cBhvr>
-                                    </p:animEffect>
-                                  </p:childTnLst>
-                                </p:cTn>
-                              </p:par>
-                              <p:par>
-                                <p:cTn id="601" presetID="10" presetClass="entr" presetSubtype="0" fill="hold" grpId="0" nodeType="withEffect">
-                                  <p:stCondLst>
-                                    <p:cond delay="1140"/>
-                                  </p:stCondLst>
-                                  <p:childTnLst>
-                                    <p:set>
-                                      <p:cBhvr>
-                                        <p:cTn id="602" dur="1" fill="hold">
-                                          <p:stCondLst>
-                                            <p:cond delay="0"/>
-                                          </p:stCondLst>
-                                        </p:cTn>
-                                        <p:tgtEl>
-                                          <p:spTgt spid="73"/>
-                                        </p:tgtEl>
-                                        <p:attrNameLst>
-                                          <p:attrName>style.visibility</p:attrName>
-                                        </p:attrNameLst>
-                                      </p:cBhvr>
-                                      <p:to>
-                                        <p:strVal val="visible"/>
-                                      </p:to>
-                                    </p:set>
-                                    <p:animEffect transition="in" filter="fade">
-                                      <p:cBhvr>
-                                        <p:cTn id="603" dur="550"/>
-                                        <p:tgtEl>
-                                          <p:spTgt spid="73"/>
-                                        </p:tgtEl>
-                                      </p:cBhvr>
-                                    </p:animEffect>
-                                  </p:childTnLst>
-                                </p:cTn>
-                              </p:par>
-                              <p:par>
-                                <p:cTn id="605" presetID="10" presetClass="entr" presetSubtype="0" fill="hold" grpId="0" nodeType="withEffect">
-                                  <p:stCondLst>
-                                    <p:cond delay="1260"/>
-                                  </p:stCondLst>
-                                  <p:childTnLst>
-                                    <p:set>
-                                      <p:cBhvr>
-                                        <p:cTn id="606" dur="1" fill="hold">
-                                          <p:stCondLst>
-                                            <p:cond delay="0"/>
-                                          </p:stCondLst>
-                                        </p:cTn>
-                                        <p:tgtEl>
-                                          <p:spTgt spid="74"/>
-                                        </p:tgtEl>
-                                        <p:attrNameLst>
-                                          <p:attrName>style.visibility</p:attrName>
-                                        </p:attrNameLst>
-                                      </p:cBhvr>
-                                      <p:to>
-                                        <p:strVal val="visible"/>
-                                      </p:to>
-                                    </p:set>
-                                    <p:animEffect transition="in" filter="fade">
-                                      <p:cBhvr>
-                                        <p:cTn id="607" dur="550"/>
-                                        <p:tgtEl>
-                                          <p:spTgt spid="74"/>
-                                        </p:tgtEl>
-                                      </p:cBhvr>
-                                    </p:animEffect>
-                                  </p:childTnLst>
-                                </p:cTn>
-                              </p:par>
-                              <p:par>
-                                <p:cTn id="609" presetID="10" presetClass="entr" presetSubtype="0" fill="hold" grpId="0" nodeType="withEffect">
-                                  <p:stCondLst>
-                                    <p:cond delay="1380"/>
-                                  </p:stCondLst>
-                                  <p:childTnLst>
-                                    <p:set>
-                                      <p:cBhvr>
-                                        <p:cTn id="610" dur="1" fill="hold">
-                                          <p:stCondLst>
-                                            <p:cond delay="0"/>
-                                          </p:stCondLst>
-                                        </p:cTn>
-                                        <p:tgtEl>
-                                          <p:spTgt spid="75"/>
-                                        </p:tgtEl>
-                                        <p:attrNameLst>
-                                          <p:attrName>style.visibility</p:attrName>
-                                        </p:attrNameLst>
-                                      </p:cBhvr>
-                                      <p:to>
-                                        <p:strVal val="visible"/>
-                                      </p:to>
-                                    </p:set>
-                                    <p:animEffect transition="in" filter="fade">
-                                      <p:cBhvr>
-                                        <p:cTn id="611" dur="550"/>
-                                        <p:tgtEl>
-                                          <p:spTgt spid="75"/>
-                                        </p:tgtEl>
-                                      </p:cBhvr>
-                                    </p:animEffect>
-                                  </p:childTnLst>
-                                </p:cTn>
-                              </p:par>
-                              <p:par>
-                                <p:cTn id="613" presetID="10" presetClass="entr" presetSubtype="0" fill="hold" grpId="0" nodeType="withEffect">
-                                  <p:stCondLst>
-                                    <p:cond delay="1500"/>
-                                  </p:stCondLst>
-                                  <p:childTnLst>
-                                    <p:set>
-                                      <p:cBhvr>
-                                        <p:cTn id="614" dur="1" fill="hold">
-                                          <p:stCondLst>
-                                            <p:cond delay="0"/>
-                                          </p:stCondLst>
-                                        </p:cTn>
-                                        <p:tgtEl>
-                                          <p:spTgt spid="76"/>
-                                        </p:tgtEl>
-                                        <p:attrNameLst>
-                                          <p:attrName>style.visibility</p:attrName>
-                                        </p:attrNameLst>
-                                      </p:cBhvr>
-                                      <p:to>
-                                        <p:strVal val="visible"/>
-                                      </p:to>
-                                    </p:set>
-                                    <p:animEffect transition="in" filter="fade">
-                                      <p:cBhvr>
-                                        <p:cTn id="615" dur="550"/>
-                                        <p:tgtEl>
-                                          <p:spTgt spid="76"/>
-                                        </p:tgtEl>
-                                      </p:cBhvr>
-                                    </p:animEffect>
-                                  </p:childTnLst>
-                                </p:cTn>
-                              </p:par>
-                              <p:par>
-                                <p:cTn id="617" presetID="10" presetClass="entr" presetSubtype="0" fill="hold" grpId="0" nodeType="withEffect">
-                                  <p:stCondLst>
-                                    <p:cond delay="1620"/>
-                                  </p:stCondLst>
-                                  <p:childTnLst>
-                                    <p:set>
-                                      <p:cBhvr>
-                                        <p:cTn id="618" dur="1" fill="hold">
-                                          <p:stCondLst>
-                                            <p:cond delay="0"/>
-                                          </p:stCondLst>
-                                        </p:cTn>
-                                        <p:tgtEl>
-                                          <p:spTgt spid="77"/>
-                                        </p:tgtEl>
-                                        <p:attrNameLst>
-                                          <p:attrName>style.visibility</p:attrName>
-                                        </p:attrNameLst>
-                                      </p:cBhvr>
-                                      <p:to>
-                                        <p:strVal val="visible"/>
-                                      </p:to>
-                                    </p:set>
-                                    <p:animEffect transition="in" filter="fade">
-                                      <p:cBhvr>
-                                        <p:cTn id="619" dur="550"/>
-                                        <p:tgtEl>
-                                          <p:spTgt spid="77"/>
+                                          <p:spTgt spid="64"/>
                                         </p:tgtEl>
                                       </p:cBhvr>
                                     </p:animEffect>
@@ -24845,14 +23911,14 @@
                             </p:stCondLst>
                             <p:childTnLst>
                               <p:par>
-                                <p:cTn id="621" presetID="42" presetClass="entr" presetSubtype="0" fill="hold" grpId="0" nodeType="afterEffect">
+                                <p:cTn id="569" presetID="42" presetClass="entr" presetSubtype="0" fill="hold" grpId="0" nodeType="afterEffect">
                                   <p:stCondLst>
                                     <p:cond delay="0"/>
                                   </p:stCondLst>
                                   <p:childTnLst>
                                     <p:set>
                                       <p:cBhvr>
-                                        <p:cTn id="622" dur="1" fill="hold">
+                                        <p:cTn id="570" dur="1" fill="hold">
                                           <p:stCondLst>
                                             <p:cond delay="0"/>
                                           </p:stCondLst>
@@ -24870,7 +23936,7 @@
                                     </p:set>
                                     <p:animEffect transition="in" filter="fade">
                                       <p:cBhvr>
-                                        <p:cTn id="623" dur="550"/>
+                                        <p:cTn id="571" dur="550"/>
                                         <p:tgtEl>
                                           <p:spTgt spid="11"/>
                                         </p:tgtEl>
@@ -24878,7 +23944,7 @@
                                     </p:animEffect>
                                     <p:anim calcmode="lin" valueType="num">
                                       <p:cBhvr additive="base">
-                                        <p:cTn id="624" dur="550" fill="hold"/>
+                                        <p:cTn id="572" dur="550" fill="hold"/>
                                         <p:tgtEl>
                                           <p:spTgt spid="11"/>
                                         </p:tgtEl>
@@ -24903,14 +23969,14 @@
                                 </p:cTn>
                               </p:par>
                               <p:par>
-                                <p:cTn id="625" presetID="42" presetClass="entr" presetSubtype="0" fill="hold" grpId="0" nodeType="withEffect">
+                                <p:cTn id="573" presetID="42" presetClass="entr" presetSubtype="0" fill="hold" grpId="0" nodeType="withEffect">
                                   <p:stCondLst>
                                     <p:cond delay="300"/>
                                   </p:stCondLst>
                                   <p:childTnLst>
                                     <p:set>
                                       <p:cBhvr>
-                                        <p:cTn id="626" dur="1" fill="hold">
+                                        <p:cTn id="574" dur="1" fill="hold">
                                           <p:stCondLst>
                                             <p:cond delay="0"/>
                                           </p:stCondLst>
@@ -24928,7 +23994,7 @@
                                     </p:set>
                                     <p:animEffect transition="in" filter="fade">
                                       <p:cBhvr>
-                                        <p:cTn id="627" dur="550"/>
+                                        <p:cTn id="575" dur="550"/>
                                         <p:tgtEl>
                                           <p:spTgt spid="14"/>
                                         </p:tgtEl>
@@ -24936,7 +24002,7 @@
                                     </p:animEffect>
                                     <p:anim calcmode="lin" valueType="num">
                                       <p:cBhvr additive="base">
-                                        <p:cTn id="628" dur="550" fill="hold"/>
+                                        <p:cTn id="576" dur="550" fill="hold"/>
                                         <p:tgtEl>
                                           <p:spTgt spid="14"/>
                                         </p:tgtEl>
@@ -24961,14 +24027,14 @@
                                 </p:cTn>
                               </p:par>
                               <p:par>
-                                <p:cTn id="629" presetID="42" presetClass="entr" presetSubtype="0" fill="hold" grpId="0" nodeType="withEffect">
+                                <p:cTn id="577" presetID="42" presetClass="entr" presetSubtype="0" fill="hold" grpId="0" nodeType="withEffect">
                                   <p:stCondLst>
                                     <p:cond delay="520"/>
                                   </p:stCondLst>
                                   <p:childTnLst>
                                     <p:set>
                                       <p:cBhvr>
-                                        <p:cTn id="630" dur="1" fill="hold">
+                                        <p:cTn id="578" dur="1" fill="hold">
                                           <p:stCondLst>
                                             <p:cond delay="0"/>
                                           </p:stCondLst>
@@ -24986,7 +24052,7 @@
                                     </p:set>
                                     <p:animEffect transition="in" filter="fade">
                                       <p:cBhvr>
-                                        <p:cTn id="631" dur="550"/>
+                                        <p:cTn id="579" dur="550"/>
                                         <p:tgtEl>
                                           <p:spTgt spid="17"/>
                                         </p:tgtEl>
@@ -24994,7 +24060,7 @@
                                     </p:animEffect>
                                     <p:anim calcmode="lin" valueType="num">
                                       <p:cBhvr additive="base">
-                                        <p:cTn id="632" dur="550" fill="hold"/>
+                                        <p:cTn id="580" dur="550" fill="hold"/>
                                         <p:tgtEl>
                                           <p:spTgt spid="17"/>
                                         </p:tgtEl>
@@ -25019,14 +24085,14 @@
                                 </p:cTn>
                               </p:par>
                               <p:par>
-                                <p:cTn id="633" presetID="42" presetClass="entr" presetSubtype="0" fill="hold" grpId="0" nodeType="withEffect">
+                                <p:cTn id="581" presetID="42" presetClass="entr" presetSubtype="0" fill="hold" grpId="0" nodeType="withEffect">
                                   <p:stCondLst>
                                     <p:cond delay="740"/>
                                   </p:stCondLst>
                                   <p:childTnLst>
                                     <p:set>
                                       <p:cBhvr>
-                                        <p:cTn id="634" dur="1" fill="hold">
+                                        <p:cTn id="582" dur="1" fill="hold">
                                           <p:stCondLst>
                                             <p:cond delay="0"/>
                                           </p:stCondLst>
@@ -25044,7 +24110,7 @@
                                     </p:set>
                                     <p:animEffect transition="in" filter="fade">
                                       <p:cBhvr>
-                                        <p:cTn id="635" dur="550"/>
+                                        <p:cTn id="583" dur="550"/>
                                         <p:tgtEl>
                                           <p:spTgt spid="20"/>
                                         </p:tgtEl>
@@ -25052,7 +24118,7 @@
                                     </p:animEffect>
                                     <p:anim calcmode="lin" valueType="num">
                                       <p:cBhvr additive="base">
-                                        <p:cTn id="636" dur="550" fill="hold"/>
+                                        <p:cTn id="584" dur="550" fill="hold"/>
                                         <p:tgtEl>
                                           <p:spTgt spid="20"/>
                                         </p:tgtEl>
@@ -25077,14 +24143,14 @@
                                 </p:cTn>
                               </p:par>
                               <p:par>
-                                <p:cTn id="637" presetID="42" presetClass="entr" presetSubtype="0" fill="hold" grpId="0" nodeType="withEffect">
+                                <p:cTn id="585" presetID="42" presetClass="entr" presetSubtype="0" fill="hold" grpId="0" nodeType="withEffect">
                                   <p:stCondLst>
                                     <p:cond delay="950"/>
                                   </p:stCondLst>
                                   <p:childTnLst>
                                     <p:set>
                                       <p:cBhvr>
-                                        <p:cTn id="638" dur="1" fill="hold">
+                                        <p:cTn id="586" dur="1" fill="hold">
                                           <p:stCondLst>
                                             <p:cond delay="0"/>
                                           </p:stCondLst>
@@ -25102,7 +24168,7 @@
                                     </p:set>
                                     <p:animEffect transition="in" filter="fade">
                                       <p:cBhvr>
-                                        <p:cTn id="639" dur="550"/>
+                                        <p:cTn id="587" dur="550"/>
                                         <p:tgtEl>
                                           <p:spTgt spid="21"/>
                                         </p:tgtEl>
@@ -25110,7 +24176,7 @@
                                     </p:animEffect>
                                     <p:anim calcmode="lin" valueType="num">
                                       <p:cBhvr additive="base">
-                                        <p:cTn id="640" dur="550" fill="hold"/>
+                                        <p:cTn id="588" dur="550" fill="hold"/>
                                         <p:tgtEl>
                                           <p:spTgt spid="21"/>
                                         </p:tgtEl>
@@ -25135,14 +24201,14 @@
                                 </p:cTn>
                               </p:par>
                               <p:par>
-                                <p:cTn id="641" presetID="10" presetClass="entr" presetSubtype="0" fill="hold" grpId="0" nodeType="withEffect">
+                                <p:cTn id="589" presetID="10" presetClass="entr" presetSubtype="0" fill="hold" grpId="0" nodeType="withEffect">
                                   <p:stCondLst>
                                     <p:cond delay="1100"/>
                                   </p:stCondLst>
                                   <p:childTnLst>
                                     <p:set>
                                       <p:cBhvr>
-                                        <p:cTn id="642" dur="1" fill="hold">
+                                        <p:cTn id="590" dur="1" fill="hold">
                                           <p:stCondLst>
                                             <p:cond delay="0"/>
                                           </p:stCondLst>
@@ -25160,7 +24226,7 @@
                                     </p:set>
                                     <p:animEffect transition="in" filter="fade">
                                       <p:cBhvr>
-                                        <p:cTn id="643" dur="550"/>
+                                        <p:cTn id="591" dur="550"/>
                                         <p:tgtEl>
                                           <p:spTgt spid="23"/>
                                         </p:tgtEl>

</xml_diff>